<commit_message>
CrowdStrike proposal: apply review feedback (stat baselines, support wording, current-state slide)
Co-Authored-By: Claude Opus 5.5 <noreply@anthropic.com>
Claude-Session: https://claude.ai/code/session_01AC58wvp3ibSdWMcWgRepkj
</commit_message>
<xml_diff>
--- a/ENG._CrowdStrike_Falcon_Proposal_for_Westin_Resort_Guam_SECUKOREA.pptx
+++ b/ENG._CrowdStrike_Falcon_Proposal_for_Westin_Resort_Guam_SECUKOREA.pptx
@@ -5,17 +5,17 @@
     <p:sldMasterId id="2147483648" r:id="rId1"/>
   </p:sldMasterIdLst>
   <p:notesMasterIdLst>
-    <p:notesMasterId r:id="rId20"/>
+    <p:notesMasterId r:id="rId10"/>
   </p:notesMasterIdLst>
   <p:sldIdLst>
     <p:sldId id="256" r:id="rId2"/>
-    <p:sldId id="259" r:id="rId5"/>
-    <p:sldId id="261" r:id="rId7"/>
-    <p:sldId id="268" r:id="rId13"/>
-    <p:sldId id="273" r:id="rId18"/>
-    <p:sldId id="270" r:id="rId15"/>
-    <p:sldId id="276" r:id="rId17"/>
-    <p:sldId id="275" r:id="rId19"/>
+    <p:sldId id="258" r:id="rId3"/>
+    <p:sldId id="259" r:id="rId4"/>
+    <p:sldId id="261" r:id="rId5"/>
+    <p:sldId id="268" r:id="rId6"/>
+    <p:sldId id="273" r:id="rId7"/>
+    <p:sldId id="276" r:id="rId8"/>
+    <p:sldId id="275" r:id="rId9"/>
   </p:sldIdLst>
   <p:sldSz cx="12192000" cy="6858000"/>
   <p:notesSz cx="6858000" cy="12192000"/>
@@ -331,7 +331,7 @@
 </p:notes>
 </file>
 
-<file path=ppt/notesSlides/notesSlide12.xml><?xml version="1.0" encoding="utf-8"?>
+<file path=ppt/notesSlides/notesSlide2.xml><?xml version="1.0" encoding="utf-8"?>
 <p:notes xmlns:a="http://schemas.openxmlformats.org/drawingml/2006/main" xmlns:r="http://schemas.openxmlformats.org/officeDocument/2006/relationships" xmlns:p="http://schemas.openxmlformats.org/presentationml/2006/main">
   <p:cSld>
     <p:spTree>
@@ -377,7 +377,7 @@
           <a:p>
             <a:r>
               <a:rPr lang="en-US" dirty="0"/>
-              <a:t>A simple side-by-side view. A scanner such as Nessus finds and reports weaknesses. CrowdStrike Falcon stops attacks automatically, every second, and comes with SECUKOREA 24/7 support.</a:t>
+              <a:t>Set the scene: a 24/7 resort with a small IT team and no endpoint protection. A scan-centric approach only produces findings and leaves gaps between scans; the resort needs protection that acts on its own.</a:t>
             </a:r>
           </a:p>
         </p:txBody>
@@ -399,7 +399,7 @@
           <a:p>
             <a:fld id="{F7021451-1387-4CA6-816F-3879F97B5CBC}" type="slidenum">
               <a:rPr lang="en-US"/>
-              <a:t>12</a:t>
+              <a:t>2</a:t>
             </a:fld>
             <a:endParaRPr lang="en-US"/>
           </a:p>
@@ -418,7 +418,7 @@
 </p:notes>
 </file>
 
-<file path=ppt/notesSlides/notesSlide14.xml><?xml version="1.0" encoding="utf-8"?>
+<file path=ppt/notesSlides/notesSlide3.xml><?xml version="1.0" encoding="utf-8"?>
 <p:notes xmlns:a="http://schemas.openxmlformats.org/drawingml/2006/main" xmlns:r="http://schemas.openxmlformats.org/officeDocument/2006/relationships" xmlns:p="http://schemas.openxmlformats.org/presentationml/2006/main">
   <p:cSld>
     <p:spTree>
@@ -464,7 +464,7 @@
           <a:p>
             <a:r>
               <a:rPr lang="en-US" dirty="0"/>
-              <a:t>Proof in two forms. First, a real ransomware attack documented by CrowdStrike: Falcon detected the intruder and blocked every step before a single file was encrypted. Second, results from customers, including a hospitality chain, and independent test results.</a:t>
+              <a:t>Why this matters now: the fastest recorded breakout took 27 seconds, attacks by AI-enabled hackers rose 89% year over year, zero-days exploited before disclosure rose 42%, and 78% of surveyed organizations were hit by ransomware last year.</a:t>
             </a:r>
           </a:p>
         </p:txBody>
@@ -486,268 +486,7 @@
           <a:p>
             <a:fld id="{F7021451-1387-4CA6-816F-3879F97B5CBC}" type="slidenum">
               <a:rPr lang="en-US"/>
-              <a:t>14</a:t>
-            </a:fld>
-            <a:endParaRPr lang="en-US"/>
-          </a:p>
-        </p:txBody>
-      </p:sp>
-    </p:spTree>
-    <p:extLst>
-      <p:ext uri="{BB962C8B-B14F-4D97-AF65-F5344CB8AC3E}">
-        <p14:creationId xmlns:p14="http://schemas.microsoft.com/office/powerpoint/2010/main" val="1024086991"/>
-      </p:ext>
-    </p:extLst>
-  </p:cSld>
-  <p:clrMapOvr>
-    <a:masterClrMapping/>
-  </p:clrMapOvr>
-</p:notes>
-</file>
-
-<file path=ppt/notesSlides/notesSlide16.xml><?xml version="1.0" encoding="utf-8"?>
-<p:notes xmlns:a="http://schemas.openxmlformats.org/drawingml/2006/main" xmlns:r="http://schemas.openxmlformats.org/officeDocument/2006/relationships" xmlns:p="http://schemas.openxmlformats.org/presentationml/2006/main">
-  <p:cSld>
-    <p:spTree>
-      <p:nvGrpSpPr>
-        <p:cNvPr id="1" name=""/>
-        <p:cNvGrpSpPr/>
-        <p:nvPr/>
-      </p:nvGrpSpPr>
-      <p:grpSpPr>
-        <a:xfrm>
-          <a:off x="0" y="0"/>
-          <a:ext cx="0" cy="0"/>
-          <a:chOff x="0" y="0"/>
-          <a:chExt cx="0" cy="0"/>
-        </a:xfrm>
-      </p:grpSpPr>
-      <p:sp>
-        <p:nvSpPr>
-          <p:cNvPr id="2" name="Slide Image Placeholder 1"/>
-          <p:cNvSpPr>
-            <a:spLocks noGrp="1" noRot="1" noChangeAspect="1"/>
-          </p:cNvSpPr>
-          <p:nvPr>
-            <p:ph type="sldImg"/>
-          </p:nvPr>
-        </p:nvSpPr>
-        <p:spPr/>
-      </p:sp>
-      <p:sp>
-        <p:nvSpPr>
-          <p:cNvPr id="3" name="Notes Placeholder 2"/>
-          <p:cNvSpPr>
-            <a:spLocks noGrp="1"/>
-          </p:cNvSpPr>
-          <p:nvPr>
-            <p:ph type="body" idx="1"/>
-          </p:nvPr>
-        </p:nvSpPr>
-        <p:spPr/>
-        <p:txBody>
-          <a:bodyPr/>
-          <a:lstStyle/>
-          <a:p>
-            <a:r>
-              <a:rPr lang="en-US" dirty="0"/>
-              <a:t>After deployment, SECUKOREA supports the resort 24/7 remotely, with a dedicated engineer as a single point of contact. For serious incidents, CrowdStrike partner SK shieldus steps in with its incident response team and response-time commitments.</a:t>
-            </a:r>
-          </a:p>
-        </p:txBody>
-      </p:sp>
-      <p:sp>
-        <p:nvSpPr>
-          <p:cNvPr id="4" name="Slide Number Placeholder 3"/>
-          <p:cNvSpPr>
-            <a:spLocks noGrp="1"/>
-          </p:cNvSpPr>
-          <p:nvPr>
-            <p:ph type="sldNum" sz="quarter" idx="10"/>
-          </p:nvPr>
-        </p:nvSpPr>
-        <p:spPr/>
-        <p:txBody>
-          <a:bodyPr/>
-          <a:lstStyle/>
-          <a:p>
-            <a:fld id="{F7021451-1387-4CA6-816F-3879F97B5CBC}" type="slidenum">
-              <a:rPr lang="en-US"/>
-              <a:t>16</a:t>
-            </a:fld>
-            <a:endParaRPr lang="en-US"/>
-          </a:p>
-        </p:txBody>
-      </p:sp>
-    </p:spTree>
-    <p:extLst>
-      <p:ext uri="{BB962C8B-B14F-4D97-AF65-F5344CB8AC3E}">
-        <p14:creationId xmlns:p14="http://schemas.microsoft.com/office/powerpoint/2010/main" val="1024086991"/>
-      </p:ext>
-    </p:extLst>
-  </p:cSld>
-  <p:clrMapOvr>
-    <a:masterClrMapping/>
-  </p:clrMapOvr>
-</p:notes>
-</file>
-
-<file path=ppt/notesSlides/notesSlide17.xml><?xml version="1.0" encoding="utf-8"?>
-<p:notes xmlns:a="http://schemas.openxmlformats.org/drawingml/2006/main" xmlns:r="http://schemas.openxmlformats.org/officeDocument/2006/relationships" xmlns:p="http://schemas.openxmlformats.org/presentationml/2006/main">
-  <p:cSld>
-    <p:spTree>
-      <p:nvGrpSpPr>
-        <p:cNvPr id="1" name=""/>
-        <p:cNvGrpSpPr/>
-        <p:nvPr/>
-      </p:nvGrpSpPr>
-      <p:grpSpPr>
-        <a:xfrm>
-          <a:off x="0" y="0"/>
-          <a:ext cx="0" cy="0"/>
-          <a:chOff x="0" y="0"/>
-          <a:chExt cx="0" cy="0"/>
-        </a:xfrm>
-      </p:grpSpPr>
-      <p:sp>
-        <p:nvSpPr>
-          <p:cNvPr id="2" name="Slide Image Placeholder 1"/>
-          <p:cNvSpPr>
-            <a:spLocks noGrp="1" noRot="1" noChangeAspect="1"/>
-          </p:cNvSpPr>
-          <p:nvPr>
-            <p:ph type="sldImg"/>
-          </p:nvPr>
-        </p:nvSpPr>
-        <p:spPr/>
-      </p:sp>
-      <p:sp>
-        <p:nvSpPr>
-          <p:cNvPr id="3" name="Notes Placeholder 2"/>
-          <p:cNvSpPr>
-            <a:spLocks noGrp="1"/>
-          </p:cNvSpPr>
-          <p:nvPr>
-            <p:ph type="body" idx="1"/>
-          </p:nvPr>
-        </p:nvSpPr>
-        <p:spPr/>
-        <p:txBody>
-          <a:bodyPr/>
-          <a:lstStyle/>
-          <a:p>
-            <a:r>
-              <a:rPr lang="en-US" dirty="0"/>
-              <a:t>The before and after in plain terms, and the four outcomes that matter to hotel management: guest trust, business continuity, less work for the IT team, and compliance support.</a:t>
-            </a:r>
-          </a:p>
-        </p:txBody>
-      </p:sp>
-      <p:sp>
-        <p:nvSpPr>
-          <p:cNvPr id="4" name="Slide Number Placeholder 3"/>
-          <p:cNvSpPr>
-            <a:spLocks noGrp="1"/>
-          </p:cNvSpPr>
-          <p:nvPr>
-            <p:ph type="sldNum" sz="quarter" idx="10"/>
-          </p:nvPr>
-        </p:nvSpPr>
-        <p:spPr/>
-        <p:txBody>
-          <a:bodyPr/>
-          <a:lstStyle/>
-          <a:p>
-            <a:fld id="{F7021451-1387-4CA6-816F-3879F97B5CBC}" type="slidenum">
-              <a:rPr lang="en-US"/>
-              <a:t>17</a:t>
-            </a:fld>
-            <a:endParaRPr lang="en-US"/>
-          </a:p>
-        </p:txBody>
-      </p:sp>
-    </p:spTree>
-    <p:extLst>
-      <p:ext uri="{BB962C8B-B14F-4D97-AF65-F5344CB8AC3E}">
-        <p14:creationId xmlns:p14="http://schemas.microsoft.com/office/powerpoint/2010/main" val="1024086991"/>
-      </p:ext>
-    </p:extLst>
-  </p:cSld>
-  <p:clrMapOvr>
-    <a:masterClrMapping/>
-  </p:clrMapOvr>
-</p:notes>
-</file>
-
-<file path=ppt/notesSlides/notesSlide18.xml><?xml version="1.0" encoding="utf-8"?>
-<p:notes xmlns:a="http://schemas.openxmlformats.org/drawingml/2006/main" xmlns:r="http://schemas.openxmlformats.org/officeDocument/2006/relationships" xmlns:p="http://schemas.openxmlformats.org/presentationml/2006/main">
-  <p:cSld>
-    <p:spTree>
-      <p:nvGrpSpPr>
-        <p:cNvPr id="1" name=""/>
-        <p:cNvGrpSpPr/>
-        <p:nvPr/>
-      </p:nvGrpSpPr>
-      <p:grpSpPr>
-        <a:xfrm>
-          <a:off x="0" y="0"/>
-          <a:ext cx="0" cy="0"/>
-          <a:chOff x="0" y="0"/>
-          <a:chExt cx="0" cy="0"/>
-        </a:xfrm>
-      </p:grpSpPr>
-      <p:sp>
-        <p:nvSpPr>
-          <p:cNvPr id="2" name="Slide Image Placeholder 1"/>
-          <p:cNvSpPr>
-            <a:spLocks noGrp="1" noRot="1" noChangeAspect="1"/>
-          </p:cNvSpPr>
-          <p:nvPr>
-            <p:ph type="sldImg"/>
-          </p:nvPr>
-        </p:nvSpPr>
-        <p:spPr/>
-      </p:sp>
-      <p:sp>
-        <p:nvSpPr>
-          <p:cNvPr id="3" name="Notes Placeholder 2"/>
-          <p:cNvSpPr>
-            <a:spLocks noGrp="1"/>
-          </p:cNvSpPr>
-          <p:nvPr>
-            <p:ph type="body" idx="1"/>
-          </p:nvPr>
-        </p:nvSpPr>
-        <p:spPr/>
-        <p:txBody>
-          <a:bodyPr/>
-          <a:lstStyle/>
-          <a:p>
-            <a:r>
-              <a:rPr lang="en-US" dirty="0"/>
-              <a:t>Thank the audience and open the floor for questions.</a:t>
-            </a:r>
-          </a:p>
-        </p:txBody>
-      </p:sp>
-      <p:sp>
-        <p:nvSpPr>
-          <p:cNvPr id="4" name="Slide Number Placeholder 3"/>
-          <p:cNvSpPr>
-            <a:spLocks noGrp="1"/>
-          </p:cNvSpPr>
-          <p:nvPr>
-            <p:ph type="sldNum" sz="quarter" idx="10"/>
-          </p:nvPr>
-        </p:nvSpPr>
-        <p:spPr/>
-        <p:txBody>
-          <a:bodyPr/>
-          <a:lstStyle/>
-          <a:p>
-            <a:fld id="{F7021451-1387-4CA6-816F-3879F97B5CBC}" type="slidenum">
-              <a:rPr lang="en-US"/>
-              <a:t>18</a:t>
+              <a:t>3</a:t>
             </a:fld>
             <a:endParaRPr lang="en-US"/>
           </a:p>
@@ -812,7 +551,7 @@
           <a:p>
             <a:r>
               <a:rPr lang="en-US" dirty="0"/>
-              <a:t>Why this matters now: hackers spread in seconds, use AI, and attack weaknesses before fixes exist. Most organizations were hit by ransomware last year. Protection must be automatic and always on.</a:t>
+              <a:t>Analogy for non-technical stakeholders: a scanner such as Nessus is the scheduled fire-safety inspection. Falcon is the smoke detectors, sprinklers and security team that act when a fire actually starts.</a:t>
             </a:r>
           </a:p>
         </p:txBody>
@@ -835,6 +574,93 @@
             <a:fld id="{F7021451-1387-4CA6-816F-3879F97B5CBC}" type="slidenum">
               <a:rPr lang="en-US"/>
               <a:t>4</a:t>
+            </a:fld>
+            <a:endParaRPr lang="en-US"/>
+          </a:p>
+        </p:txBody>
+      </p:sp>
+    </p:spTree>
+    <p:extLst>
+      <p:ext uri="{BB962C8B-B14F-4D97-AF65-F5344CB8AC3E}">
+        <p14:creationId xmlns:p14="http://schemas.microsoft.com/office/powerpoint/2010/main" val="1024086991"/>
+      </p:ext>
+    </p:extLst>
+  </p:cSld>
+  <p:clrMapOvr>
+    <a:masterClrMapping/>
+  </p:clrMapOvr>
+</p:notes>
+</file>
+
+<file path=ppt/notesSlides/notesSlide5.xml><?xml version="1.0" encoding="utf-8"?>
+<p:notes xmlns:a="http://schemas.openxmlformats.org/drawingml/2006/main" xmlns:r="http://schemas.openxmlformats.org/officeDocument/2006/relationships" xmlns:p="http://schemas.openxmlformats.org/presentationml/2006/main">
+  <p:cSld>
+    <p:spTree>
+      <p:nvGrpSpPr>
+        <p:cNvPr id="1" name=""/>
+        <p:cNvGrpSpPr/>
+        <p:nvPr/>
+      </p:nvGrpSpPr>
+      <p:grpSpPr>
+        <a:xfrm>
+          <a:off x="0" y="0"/>
+          <a:ext cx="0" cy="0"/>
+          <a:chOff x="0" y="0"/>
+          <a:chExt cx="0" cy="0"/>
+        </a:xfrm>
+      </p:grpSpPr>
+      <p:sp>
+        <p:nvSpPr>
+          <p:cNvPr id="2" name="Slide Image Placeholder 1"/>
+          <p:cNvSpPr>
+            <a:spLocks noGrp="1" noRot="1" noChangeAspect="1"/>
+          </p:cNvSpPr>
+          <p:nvPr>
+            <p:ph type="sldImg"/>
+          </p:nvPr>
+        </p:nvSpPr>
+        <p:spPr/>
+      </p:sp>
+      <p:sp>
+        <p:nvSpPr>
+          <p:cNvPr id="3" name="Notes Placeholder 2"/>
+          <p:cNvSpPr>
+            <a:spLocks noGrp="1"/>
+          </p:cNvSpPr>
+          <p:nvPr>
+            <p:ph type="body" idx="1"/>
+          </p:nvPr>
+        </p:nvSpPr>
+        <p:spPr/>
+        <p:txBody>
+          <a:bodyPr/>
+          <a:lstStyle/>
+          <a:p>
+            <a:r>
+              <a:rPr lang="en-US" dirty="0"/>
+              <a:t>A simple side-by-side view. A scanner such as Nessus finds and reports weaknesses. CrowdStrike Falcon stops attacks automatically, every second, and comes with SECUKOREA 24/7 support.</a:t>
+            </a:r>
+          </a:p>
+        </p:txBody>
+      </p:sp>
+      <p:sp>
+        <p:nvSpPr>
+          <p:cNvPr id="4" name="Slide Number Placeholder 3"/>
+          <p:cNvSpPr>
+            <a:spLocks noGrp="1"/>
+          </p:cNvSpPr>
+          <p:nvPr>
+            <p:ph type="sldNum" sz="quarter" idx="10"/>
+          </p:nvPr>
+        </p:nvSpPr>
+        <p:spPr/>
+        <p:txBody>
+          <a:bodyPr/>
+          <a:lstStyle/>
+          <a:p>
+            <a:fld id="{F7021451-1387-4CA6-816F-3879F97B5CBC}" type="slidenum">
+              <a:rPr lang="en-US"/>
+              <a:t>5</a:t>
             </a:fld>
             <a:endParaRPr lang="en-US"/>
           </a:p>
@@ -899,7 +725,7 @@
           <a:p>
             <a:r>
               <a:rPr lang="en-US" dirty="0"/>
-              <a:t>Analogy for non-technical stakeholders: a scanner such as Nessus is the scheduled fire-safety inspection. Falcon is the smoke detectors, sprinklers and security team that act when a fire actually starts.</a:t>
+              <a:t>The before and after in plain terms, and the four outcomes that matter to hotel management: guest trust, business continuity, less work for the IT team, and compliance support.</a:t>
             </a:r>
           </a:p>
         </p:txBody>
@@ -922,6 +748,180 @@
             <a:fld id="{F7021451-1387-4CA6-816F-3879F97B5CBC}" type="slidenum">
               <a:rPr lang="en-US"/>
               <a:t>6</a:t>
+            </a:fld>
+            <a:endParaRPr lang="en-US"/>
+          </a:p>
+        </p:txBody>
+      </p:sp>
+    </p:spTree>
+    <p:extLst>
+      <p:ext uri="{BB962C8B-B14F-4D97-AF65-F5344CB8AC3E}">
+        <p14:creationId xmlns:p14="http://schemas.microsoft.com/office/powerpoint/2010/main" val="1024086991"/>
+      </p:ext>
+    </p:extLst>
+  </p:cSld>
+  <p:clrMapOvr>
+    <a:masterClrMapping/>
+  </p:clrMapOvr>
+</p:notes>
+</file>
+
+<file path=ppt/notesSlides/notesSlide7.xml><?xml version="1.0" encoding="utf-8"?>
+<p:notes xmlns:a="http://schemas.openxmlformats.org/drawingml/2006/main" xmlns:r="http://schemas.openxmlformats.org/officeDocument/2006/relationships" xmlns:p="http://schemas.openxmlformats.org/presentationml/2006/main">
+  <p:cSld>
+    <p:spTree>
+      <p:nvGrpSpPr>
+        <p:cNvPr id="1" name=""/>
+        <p:cNvGrpSpPr/>
+        <p:nvPr/>
+      </p:nvGrpSpPr>
+      <p:grpSpPr>
+        <a:xfrm>
+          <a:off x="0" y="0"/>
+          <a:ext cx="0" cy="0"/>
+          <a:chOff x="0" y="0"/>
+          <a:chExt cx="0" cy="0"/>
+        </a:xfrm>
+      </p:grpSpPr>
+      <p:sp>
+        <p:nvSpPr>
+          <p:cNvPr id="2" name="Slide Image Placeholder 1"/>
+          <p:cNvSpPr>
+            <a:spLocks noGrp="1" noRot="1" noChangeAspect="1"/>
+          </p:cNvSpPr>
+          <p:nvPr>
+            <p:ph type="sldImg"/>
+          </p:nvPr>
+        </p:nvSpPr>
+        <p:spPr/>
+      </p:sp>
+      <p:sp>
+        <p:nvSpPr>
+          <p:cNvPr id="3" name="Notes Placeholder 2"/>
+          <p:cNvSpPr>
+            <a:spLocks noGrp="1"/>
+          </p:cNvSpPr>
+          <p:nvPr>
+            <p:ph type="body" idx="1"/>
+          </p:nvPr>
+        </p:nvSpPr>
+        <p:spPr/>
+        <p:txBody>
+          <a:bodyPr/>
+          <a:lstStyle/>
+          <a:p>
+            <a:r>
+              <a:rPr lang="en-US" dirty="0"/>
+              <a:t>After deployment, SECUKOREA supports the resort 24/7 remotely, with a dedicated engineer and direct, accountable support from first call to resolution. For serious incidents, CrowdStrike partner SK shieldus steps in with its incident response team.</a:t>
+            </a:r>
+          </a:p>
+        </p:txBody>
+      </p:sp>
+      <p:sp>
+        <p:nvSpPr>
+          <p:cNvPr id="4" name="Slide Number Placeholder 3"/>
+          <p:cNvSpPr>
+            <a:spLocks noGrp="1"/>
+          </p:cNvSpPr>
+          <p:nvPr>
+            <p:ph type="sldNum" sz="quarter" idx="10"/>
+          </p:nvPr>
+        </p:nvSpPr>
+        <p:spPr/>
+        <p:txBody>
+          <a:bodyPr/>
+          <a:lstStyle/>
+          <a:p>
+            <a:fld id="{F7021451-1387-4CA6-816F-3879F97B5CBC}" type="slidenum">
+              <a:rPr lang="en-US"/>
+              <a:t>7</a:t>
+            </a:fld>
+            <a:endParaRPr lang="en-US"/>
+          </a:p>
+        </p:txBody>
+      </p:sp>
+    </p:spTree>
+    <p:extLst>
+      <p:ext uri="{BB962C8B-B14F-4D97-AF65-F5344CB8AC3E}">
+        <p14:creationId xmlns:p14="http://schemas.microsoft.com/office/powerpoint/2010/main" val="1024086991"/>
+      </p:ext>
+    </p:extLst>
+  </p:cSld>
+  <p:clrMapOvr>
+    <a:masterClrMapping/>
+  </p:clrMapOvr>
+</p:notes>
+</file>
+
+<file path=ppt/notesSlides/notesSlide8.xml><?xml version="1.0" encoding="utf-8"?>
+<p:notes xmlns:a="http://schemas.openxmlformats.org/drawingml/2006/main" xmlns:r="http://schemas.openxmlformats.org/officeDocument/2006/relationships" xmlns:p="http://schemas.openxmlformats.org/presentationml/2006/main">
+  <p:cSld>
+    <p:spTree>
+      <p:nvGrpSpPr>
+        <p:cNvPr id="1" name=""/>
+        <p:cNvGrpSpPr/>
+        <p:nvPr/>
+      </p:nvGrpSpPr>
+      <p:grpSpPr>
+        <a:xfrm>
+          <a:off x="0" y="0"/>
+          <a:ext cx="0" cy="0"/>
+          <a:chOff x="0" y="0"/>
+          <a:chExt cx="0" cy="0"/>
+        </a:xfrm>
+      </p:grpSpPr>
+      <p:sp>
+        <p:nvSpPr>
+          <p:cNvPr id="2" name="Slide Image Placeholder 1"/>
+          <p:cNvSpPr>
+            <a:spLocks noGrp="1" noRot="1" noChangeAspect="1"/>
+          </p:cNvSpPr>
+          <p:nvPr>
+            <p:ph type="sldImg"/>
+          </p:nvPr>
+        </p:nvSpPr>
+        <p:spPr/>
+      </p:sp>
+      <p:sp>
+        <p:nvSpPr>
+          <p:cNvPr id="3" name="Notes Placeholder 2"/>
+          <p:cNvSpPr>
+            <a:spLocks noGrp="1"/>
+          </p:cNvSpPr>
+          <p:nvPr>
+            <p:ph type="body" idx="1"/>
+          </p:nvPr>
+        </p:nvSpPr>
+        <p:spPr/>
+        <p:txBody>
+          <a:bodyPr/>
+          <a:lstStyle/>
+          <a:p>
+            <a:r>
+              <a:rPr lang="en-US" dirty="0"/>
+              <a:t>Thank the audience and open the floor for questions.</a:t>
+            </a:r>
+          </a:p>
+        </p:txBody>
+      </p:sp>
+      <p:sp>
+        <p:nvSpPr>
+          <p:cNvPr id="4" name="Slide Number Placeholder 3"/>
+          <p:cNvSpPr>
+            <a:spLocks noGrp="1"/>
+          </p:cNvSpPr>
+          <p:nvPr>
+            <p:ph type="sldNum" sz="quarter" idx="10"/>
+          </p:nvPr>
+        </p:nvSpPr>
+        <p:spPr/>
+        <p:txBody>
+          <a:bodyPr/>
+          <a:lstStyle/>
+          <a:p>
+            <a:fld id="{F7021451-1387-4CA6-816F-3879F97B5CBC}" type="slidenum">
+              <a:rPr lang="en-US"/>
+              <a:t>8</a:t>
             </a:fld>
             <a:endParaRPr lang="en-US"/>
           </a:p>
@@ -1539,6 +1539,17 @@
               </a:rPr>
               <a:t>SECUKOREA Inc.</a:t>
             </a:r>
+            <a:r>
+              <a:rPr lang="ko-KR" altLang="en-US" sz="1500" dirty="0">
+                <a:solidFill>
+                  <a:srgbClr val="FFFFFF"/>
+                </a:solidFill>
+                <a:latin typeface="Calibri" pitchFamily="34" charset="0"/>
+                <a:ea typeface="Calibri" pitchFamily="34" charset="-122"/>
+                <a:cs typeface="Calibri" pitchFamily="34" charset="-120"/>
+              </a:rPr>
+              <a:t/>
+            </a:r>
             <a:endParaRPr lang="en-US" sz="1500" dirty="0"/>
           </a:p>
         </p:txBody>
@@ -1795,6 +1806,1165 @@
 </file>
 
 <file path=ppt/slides/slide2.xml><?xml version="1.0" encoding="utf-8"?>
+<p:sld xmlns:a="http://schemas.openxmlformats.org/drawingml/2006/main" xmlns:r="http://schemas.openxmlformats.org/officeDocument/2006/relationships" xmlns:p="http://schemas.openxmlformats.org/presentationml/2006/main">
+  <p:cSld>
+    <p:spTree>
+      <p:nvGrpSpPr>
+        <p:cNvPr id="1" name=""/>
+        <p:cNvGrpSpPr/>
+        <p:nvPr/>
+      </p:nvGrpSpPr>
+      <p:grpSpPr>
+        <a:xfrm>
+          <a:off x="0" y="0"/>
+          <a:ext cx="0" cy="0"/>
+          <a:chOff x="0" y="0"/>
+          <a:chExt cx="0" cy="0"/>
+        </a:xfrm>
+      </p:grpSpPr>
+      <p:sp>
+        <p:nvSpPr>
+          <p:cNvPr id="2" name="Text 0"/>
+          <p:cNvSpPr txBox="1"/>
+          <p:nvPr/>
+        </p:nvSpPr>
+        <p:spPr>
+          <a:xfrm>
+            <a:off x="548640" y="384048"/>
+            <a:ext cx="8229600" cy="256032"/>
+          </a:xfrm>
+          <a:prstGeom prst="rect">
+            <a:avLst/>
+          </a:prstGeom>
+          <a:noFill/>
+          <a:ln/>
+        </p:spPr>
+        <p:txBody>
+          <a:bodyPr wrap="square" lIns="0" tIns="0" rIns="0" bIns="0" rtlCol="0" anchor="t"/>
+          <a:lstStyle/>
+          <a:p>
+            <a:pPr marL="0" indent="0">
+              <a:buNone/>
+            </a:pPr>
+            <a:r>
+              <a:rPr lang="ko-KR" sz="1100" b="1" kern="0" spc="200" dirty="0">
+                <a:solidFill>
+                  <a:srgbClr val="E3202A"/>
+                </a:solidFill>
+                <a:latin typeface="Arial" pitchFamily="34" charset="0"/>
+                <a:ea typeface="맑은 고딕" pitchFamily="34" charset="-122"/>
+                <a:cs typeface="Arial" pitchFamily="34" charset="-120"/>
+              </a:rPr>
+              <a:t>01   CURRENT STATE</a:t>
+            </a:r>
+            <a:endParaRPr lang="en-US" sz="1100" dirty="0"/>
+          </a:p>
+        </p:txBody>
+      </p:sp>
+      <p:sp>
+        <p:nvSpPr>
+          <p:cNvPr id="3" name="Text 1"/>
+          <p:cNvSpPr txBox="1"/>
+          <p:nvPr/>
+        </p:nvSpPr>
+        <p:spPr>
+          <a:xfrm>
+            <a:off x="548640" y="658368"/>
+            <a:ext cx="9692640" cy="658368"/>
+          </a:xfrm>
+          <a:prstGeom prst="rect">
+            <a:avLst/>
+          </a:prstGeom>
+          <a:noFill/>
+          <a:ln/>
+        </p:spPr>
+        <p:txBody>
+          <a:bodyPr wrap="square" lIns="0" tIns="0" rIns="0" bIns="0" rtlCol="0" anchor="ctr"/>
+          <a:lstStyle/>
+          <a:p>
+            <a:pPr marL="0" indent="0">
+              <a:buNone/>
+            </a:pPr>
+            <a:r>
+              <a:rPr lang="ko-KR" sz="2800" b="1" dirty="0">
+                <a:solidFill>
+                  <a:srgbClr val="151A21"/>
+                </a:solidFill>
+                <a:latin typeface="Arial" pitchFamily="34" charset="0"/>
+                <a:ea typeface="맑은 고딕" pitchFamily="34" charset="-122"/>
+                <a:cs typeface="Arial" pitchFamily="34" charset="-120"/>
+              </a:rPr>
+              <a:t>Current Environment &amp; Security Challenges</a:t>
+            </a:r>
+            <a:endParaRPr lang="en-US" sz="2800" dirty="0"/>
+          </a:p>
+        </p:txBody>
+      </p:sp>
+      <p:pic>
+        <p:nvPicPr>
+          <p:cNvPr id="4" name="Image 0" descr="/private/tmp/claude-501/-Users-jihanvin-Desktop-NIVNAH-AI/16a96446-d9b3-40e2-af9e-a3011ae3db84/scratchpad/assets/westin_grey.png"/>
+          <p:cNvPicPr>
+            <a:picLocks noChangeAspect="1"/>
+          </p:cNvPicPr>
+          <p:nvPr/>
+        </p:nvPicPr>
+        <p:blipFill>
+          <a:blip r:embed="rId3"/>
+          <a:stretch>
+            <a:fillRect/>
+          </a:stretch>
+        </p:blipFill>
+        <p:spPr>
+          <a:xfrm>
+            <a:off x="10634472" y="402336"/>
+            <a:ext cx="1005840" cy="301752"/>
+          </a:xfrm>
+          <a:prstGeom prst="rect">
+            <a:avLst/>
+          </a:prstGeom>
+        </p:spPr>
+      </p:pic>
+      <p:sp>
+        <p:nvSpPr>
+          <p:cNvPr id="5" name="Shape 2"/>
+          <p:cNvSpPr/>
+          <p:nvPr/>
+        </p:nvSpPr>
+        <p:spPr>
+          <a:xfrm>
+            <a:off x="548640" y="1600200"/>
+            <a:ext cx="566928" cy="566928"/>
+          </a:xfrm>
+          <a:prstGeom prst="roundRect">
+            <a:avLst>
+              <a:gd name="adj" fmla="val 16129"/>
+            </a:avLst>
+          </a:prstGeom>
+          <a:solidFill>
+            <a:srgbClr val="EAEEF3"/>
+          </a:solidFill>
+          <a:ln w="12700">
+            <a:solidFill>
+              <a:srgbClr val="EAEEF3"/>
+            </a:solidFill>
+            <a:prstDash val="solid"/>
+          </a:ln>
+        </p:spPr>
+      </p:sp>
+      <p:pic>
+        <p:nvPicPr>
+          <p:cNvPr id="6" name="Image 1" descr="preencoded.png"/>
+          <p:cNvPicPr>
+            <a:picLocks noChangeAspect="1"/>
+          </p:cNvPicPr>
+          <p:nvPr/>
+        </p:nvPicPr>
+        <p:blipFill>
+          <a:blip r:embed="rId4"/>
+          <a:stretch>
+            <a:fillRect/>
+          </a:stretch>
+        </p:blipFill>
+        <p:spPr>
+          <a:xfrm>
+            <a:off x="673364" y="1724924"/>
+            <a:ext cx="317480" cy="317480"/>
+          </a:xfrm>
+          <a:prstGeom prst="rect">
+            <a:avLst/>
+          </a:prstGeom>
+        </p:spPr>
+      </p:pic>
+      <p:sp>
+        <p:nvSpPr>
+          <p:cNvPr id="7" name="Text 3"/>
+          <p:cNvSpPr txBox="1"/>
+          <p:nvPr/>
+        </p:nvSpPr>
+        <p:spPr>
+          <a:xfrm>
+            <a:off x="1325880" y="1581912"/>
+            <a:ext cx="5760720" cy="310896"/>
+          </a:xfrm>
+          <a:prstGeom prst="rect">
+            <a:avLst/>
+          </a:prstGeom>
+          <a:noFill/>
+          <a:ln/>
+        </p:spPr>
+        <p:txBody>
+          <a:bodyPr wrap="square" lIns="0" tIns="0" rIns="0" bIns="0" rtlCol="0" anchor="t"/>
+          <a:lstStyle/>
+          <a:p>
+            <a:pPr marL="0" indent="0">
+              <a:buNone/>
+            </a:pPr>
+            <a:r>
+              <a:rPr lang="ko-KR" sz="1500" b="1" dirty="0">
+                <a:solidFill>
+                  <a:srgbClr val="151A21"/>
+                </a:solidFill>
+                <a:latin typeface="Arial" pitchFamily="34" charset="0"/>
+                <a:ea typeface="맑은 고딕" pitchFamily="34" charset="-122"/>
+                <a:cs typeface="Arial" pitchFamily="34" charset="-120"/>
+              </a:rPr>
+              <a:t>24/7 Non-Stop Hospitality Operations</a:t>
+            </a:r>
+            <a:endParaRPr lang="en-US" sz="1500" dirty="0"/>
+          </a:p>
+        </p:txBody>
+      </p:sp>
+      <p:sp>
+        <p:nvSpPr>
+          <p:cNvPr id="8" name="Text 4"/>
+          <p:cNvSpPr txBox="1"/>
+          <p:nvPr/>
+        </p:nvSpPr>
+        <p:spPr>
+          <a:xfrm>
+            <a:off x="1325880" y="1929384"/>
+            <a:ext cx="5760720" cy="621792"/>
+          </a:xfrm>
+          <a:prstGeom prst="rect">
+            <a:avLst/>
+          </a:prstGeom>
+          <a:noFill/>
+          <a:ln/>
+        </p:spPr>
+        <p:txBody>
+          <a:bodyPr wrap="square" lIns="0" tIns="0" rIns="0" bIns="0" rtlCol="0" anchor="t"/>
+          <a:lstStyle/>
+          <a:p>
+            <a:pPr marL="0" indent="0">
+              <a:buNone/>
+            </a:pPr>
+            <a:r>
+              <a:rPr lang="ko-KR" sz="1200" dirty="0">
+                <a:solidFill>
+                  <a:srgbClr val="5E6978"/>
+                </a:solidFill>
+                <a:latin typeface="Calibri" pitchFamily="34" charset="0"/>
+                <a:ea typeface="맑은 고딕" pitchFamily="34" charset="-122"/>
+                <a:cs typeface="Calibri" pitchFamily="34" charset="-120"/>
+              </a:rPr>
+              <a:t>Guest personal data, payment processing, and front-desk and back-office systems must stay available and protected around the clock.</a:t>
+            </a:r>
+            <a:endParaRPr lang="en-US" sz="1200" dirty="0"/>
+          </a:p>
+        </p:txBody>
+      </p:sp>
+      <p:sp>
+        <p:nvSpPr>
+          <p:cNvPr id="9" name="Shape 5"/>
+          <p:cNvSpPr/>
+          <p:nvPr/>
+        </p:nvSpPr>
+        <p:spPr>
+          <a:xfrm>
+            <a:off x="548640" y="2697480"/>
+            <a:ext cx="566928" cy="566928"/>
+          </a:xfrm>
+          <a:prstGeom prst="roundRect">
+            <a:avLst>
+              <a:gd name="adj" fmla="val 16129"/>
+            </a:avLst>
+          </a:prstGeom>
+          <a:solidFill>
+            <a:srgbClr val="EAEEF3"/>
+          </a:solidFill>
+          <a:ln w="12700">
+            <a:solidFill>
+              <a:srgbClr val="EAEEF3"/>
+            </a:solidFill>
+            <a:prstDash val="solid"/>
+          </a:ln>
+        </p:spPr>
+      </p:sp>
+      <p:pic>
+        <p:nvPicPr>
+          <p:cNvPr id="10" name="Image 2" descr="preencoded.png"/>
+          <p:cNvPicPr>
+            <a:picLocks noChangeAspect="1"/>
+          </p:cNvPicPr>
+          <p:nvPr/>
+        </p:nvPicPr>
+        <p:blipFill>
+          <a:blip r:embed="rId5"/>
+          <a:stretch>
+            <a:fillRect/>
+          </a:stretch>
+        </p:blipFill>
+        <p:spPr>
+          <a:xfrm>
+            <a:off x="673364" y="2822204"/>
+            <a:ext cx="317480" cy="317480"/>
+          </a:xfrm>
+          <a:prstGeom prst="rect">
+            <a:avLst/>
+          </a:prstGeom>
+        </p:spPr>
+      </p:pic>
+      <p:sp>
+        <p:nvSpPr>
+          <p:cNvPr id="11" name="Text 6"/>
+          <p:cNvSpPr txBox="1"/>
+          <p:nvPr/>
+        </p:nvSpPr>
+        <p:spPr>
+          <a:xfrm>
+            <a:off x="1325880" y="2679192"/>
+            <a:ext cx="5760720" cy="310896"/>
+          </a:xfrm>
+          <a:prstGeom prst="rect">
+            <a:avLst/>
+          </a:prstGeom>
+          <a:noFill/>
+          <a:ln/>
+        </p:spPr>
+        <p:txBody>
+          <a:bodyPr wrap="square" lIns="0" tIns="0" rIns="0" bIns="0" rtlCol="0" anchor="t"/>
+          <a:lstStyle/>
+          <a:p>
+            <a:pPr marL="0" indent="0">
+              <a:buNone/>
+            </a:pPr>
+            <a:r>
+              <a:rPr lang="ko-KR" sz="1500" b="1" dirty="0">
+                <a:solidFill>
+                  <a:srgbClr val="151A21"/>
+                </a:solidFill>
+                <a:latin typeface="Arial" pitchFamily="34" charset="0"/>
+                <a:ea typeface="맑은 고딕" pitchFamily="34" charset="-122"/>
+                <a:cs typeface="Arial" pitchFamily="34" charset="-120"/>
+              </a:rPr>
+              <a:t>Limited On-Site Security Staffing</a:t>
+            </a:r>
+            <a:endParaRPr lang="en-US" sz="1500" dirty="0"/>
+          </a:p>
+        </p:txBody>
+      </p:sp>
+      <p:sp>
+        <p:nvSpPr>
+          <p:cNvPr id="12" name="Text 7"/>
+          <p:cNvSpPr txBox="1"/>
+          <p:nvPr/>
+        </p:nvSpPr>
+        <p:spPr>
+          <a:xfrm>
+            <a:off x="1325880" y="3026664"/>
+            <a:ext cx="5760720" cy="621792"/>
+          </a:xfrm>
+          <a:prstGeom prst="rect">
+            <a:avLst/>
+          </a:prstGeom>
+          <a:noFill/>
+          <a:ln/>
+        </p:spPr>
+        <p:txBody>
+          <a:bodyPr wrap="square" lIns="0" tIns="0" rIns="0" bIns="0" rtlCol="0" anchor="t"/>
+          <a:lstStyle/>
+          <a:p>
+            <a:pPr marL="0" indent="0">
+              <a:buNone/>
+            </a:pPr>
+            <a:r>
+              <a:rPr lang="ko-KR" sz="1200" dirty="0">
+                <a:solidFill>
+                  <a:srgbClr val="5E6978"/>
+                </a:solidFill>
+                <a:latin typeface="Calibri" pitchFamily="34" charset="0"/>
+                <a:ea typeface="맑은 고딕" pitchFamily="34" charset="-122"/>
+                <a:cs typeface="Calibri" pitchFamily="34" charset="-120"/>
+              </a:rPr>
+              <a:t>Without a dedicated security operations team, manual patching and case-by-case incident investigation are hard to sustain.</a:t>
+            </a:r>
+            <a:endParaRPr lang="en-US" sz="1200" dirty="0"/>
+          </a:p>
+        </p:txBody>
+      </p:sp>
+      <p:sp>
+        <p:nvSpPr>
+          <p:cNvPr id="13" name="Shape 8"/>
+          <p:cNvSpPr/>
+          <p:nvPr/>
+        </p:nvSpPr>
+        <p:spPr>
+          <a:xfrm>
+            <a:off x="548640" y="3794760"/>
+            <a:ext cx="566928" cy="566928"/>
+          </a:xfrm>
+          <a:prstGeom prst="roundRect">
+            <a:avLst>
+              <a:gd name="adj" fmla="val 16129"/>
+            </a:avLst>
+          </a:prstGeom>
+          <a:solidFill>
+            <a:srgbClr val="EAEEF3"/>
+          </a:solidFill>
+          <a:ln w="12700">
+            <a:solidFill>
+              <a:srgbClr val="EAEEF3"/>
+            </a:solidFill>
+            <a:prstDash val="solid"/>
+          </a:ln>
+        </p:spPr>
+      </p:sp>
+      <p:pic>
+        <p:nvPicPr>
+          <p:cNvPr id="14" name="Image 3" descr="preencoded.png"/>
+          <p:cNvPicPr>
+            <a:picLocks noChangeAspect="1"/>
+          </p:cNvPicPr>
+          <p:nvPr/>
+        </p:nvPicPr>
+        <p:blipFill>
+          <a:blip r:embed="rId6"/>
+          <a:stretch>
+            <a:fillRect/>
+          </a:stretch>
+        </p:blipFill>
+        <p:spPr>
+          <a:xfrm>
+            <a:off x="673364" y="3919484"/>
+            <a:ext cx="317480" cy="317480"/>
+          </a:xfrm>
+          <a:prstGeom prst="rect">
+            <a:avLst/>
+          </a:prstGeom>
+        </p:spPr>
+      </p:pic>
+      <p:sp>
+        <p:nvSpPr>
+          <p:cNvPr id="15" name="Text 9"/>
+          <p:cNvSpPr txBox="1"/>
+          <p:nvPr/>
+        </p:nvSpPr>
+        <p:spPr>
+          <a:xfrm>
+            <a:off x="1325880" y="3776472"/>
+            <a:ext cx="5760720" cy="310896"/>
+          </a:xfrm>
+          <a:prstGeom prst="rect">
+            <a:avLst/>
+          </a:prstGeom>
+          <a:noFill/>
+          <a:ln/>
+        </p:spPr>
+        <p:txBody>
+          <a:bodyPr wrap="square" lIns="0" tIns="0" rIns="0" bIns="0" rtlCol="0" anchor="t"/>
+          <a:lstStyle/>
+          <a:p>
+            <a:pPr marL="0" indent="0">
+              <a:buNone/>
+            </a:pPr>
+            <a:r>
+              <a:rPr lang="ko-KR" sz="1500" b="1" dirty="0">
+                <a:solidFill>
+                  <a:srgbClr val="151A21"/>
+                </a:solidFill>
+                <a:latin typeface="Arial" pitchFamily="34" charset="0"/>
+                <a:ea typeface="맑은 고딕" pitchFamily="34" charset="-122"/>
+                <a:cs typeface="Arial" pitchFamily="34" charset="-120"/>
+              </a:rPr>
+              <a:t>Scan-Centric Protection</a:t>
+            </a:r>
+            <a:endParaRPr lang="en-US" sz="1500" dirty="0"/>
+          </a:p>
+        </p:txBody>
+      </p:sp>
+      <p:sp>
+        <p:nvSpPr>
+          <p:cNvPr id="16" name="Text 10"/>
+          <p:cNvSpPr txBox="1"/>
+          <p:nvPr/>
+        </p:nvSpPr>
+        <p:spPr>
+          <a:xfrm>
+            <a:off x="1325880" y="4123944"/>
+            <a:ext cx="5760720" cy="621792"/>
+          </a:xfrm>
+          <a:prstGeom prst="rect">
+            <a:avLst/>
+          </a:prstGeom>
+          <a:noFill/>
+          <a:ln/>
+        </p:spPr>
+        <p:txBody>
+          <a:bodyPr wrap="square" lIns="0" tIns="0" rIns="0" bIns="0" rtlCol="0" anchor="t"/>
+          <a:lstStyle/>
+          <a:p>
+            <a:pPr marL="0" indent="0">
+              <a:buNone/>
+            </a:pPr>
+            <a:r>
+              <a:rPr lang="ko-KR" sz="1200" dirty="0">
+                <a:solidFill>
+                  <a:srgbClr val="5E6978"/>
+                </a:solidFill>
+                <a:latin typeface="Calibri" pitchFamily="34" charset="0"/>
+                <a:ea typeface="맑은 고딕" pitchFamily="34" charset="-122"/>
+                <a:cs typeface="Calibri" pitchFamily="34" charset="-120"/>
+              </a:rPr>
+              <a:t>Nessus identifies vulnerabilities, but it does not block malware or stop an attack in progress. Every follow-up action is manual — and endpoints are left unprotected between scans.</a:t>
+            </a:r>
+            <a:r>
+              <a:rPr lang="en-US" altLang="ko-KR" sz="1200" dirty="0">
+                <a:solidFill>
+                  <a:srgbClr val="5E6978"/>
+                </a:solidFill>
+                <a:latin typeface="Calibri" pitchFamily="34" charset="0"/>
+                <a:ea typeface="맑은 고딕" pitchFamily="34" charset="-122"/>
+                <a:cs typeface="Calibri" pitchFamily="34" charset="-120"/>
+              </a:rPr>
+              <a:t/>
+            </a:r>
+            <a:r>
+              <a:rPr lang="ko-KR" altLang="en-US" sz="1200" dirty="0">
+                <a:solidFill>
+                  <a:srgbClr val="5E6978"/>
+                </a:solidFill>
+                <a:latin typeface="Calibri" pitchFamily="34" charset="0"/>
+                <a:ea typeface="맑은 고딕" pitchFamily="34" charset="-122"/>
+                <a:cs typeface="Calibri" pitchFamily="34" charset="-120"/>
+              </a:rPr>
+              <a:t/>
+            </a:r>
+            <a:r>
+              <a:rPr lang="en-US" altLang="ko-KR" sz="1200" dirty="0">
+                <a:solidFill>
+                  <a:srgbClr val="5E6978"/>
+                </a:solidFill>
+                <a:latin typeface="Calibri" pitchFamily="34" charset="0"/>
+                <a:ea typeface="맑은 고딕" pitchFamily="34" charset="-122"/>
+                <a:cs typeface="Calibri" pitchFamily="34" charset="-120"/>
+              </a:rPr>
+              <a:t/>
+            </a:r>
+            <a:endParaRPr lang="en-US" sz="1200" dirty="0"/>
+          </a:p>
+        </p:txBody>
+      </p:sp>
+      <p:sp>
+        <p:nvSpPr>
+          <p:cNvPr id="17" name="Shape 11"/>
+          <p:cNvSpPr/>
+          <p:nvPr/>
+        </p:nvSpPr>
+        <p:spPr>
+          <a:xfrm>
+            <a:off x="548640" y="4892040"/>
+            <a:ext cx="566928" cy="566928"/>
+          </a:xfrm>
+          <a:prstGeom prst="roundRect">
+            <a:avLst>
+              <a:gd name="adj" fmla="val 16129"/>
+            </a:avLst>
+          </a:prstGeom>
+          <a:solidFill>
+            <a:srgbClr val="EAEEF3"/>
+          </a:solidFill>
+          <a:ln w="12700">
+            <a:solidFill>
+              <a:srgbClr val="EAEEF3"/>
+            </a:solidFill>
+            <a:prstDash val="solid"/>
+          </a:ln>
+        </p:spPr>
+      </p:sp>
+      <p:pic>
+        <p:nvPicPr>
+          <p:cNvPr id="18" name="Image 4" descr="preencoded.png"/>
+          <p:cNvPicPr>
+            <a:picLocks noChangeAspect="1"/>
+          </p:cNvPicPr>
+          <p:nvPr/>
+        </p:nvPicPr>
+        <p:blipFill>
+          <a:blip r:embed="rId7"/>
+          <a:stretch>
+            <a:fillRect/>
+          </a:stretch>
+        </p:blipFill>
+        <p:spPr>
+          <a:xfrm>
+            <a:off x="673364" y="5016764"/>
+            <a:ext cx="317480" cy="317480"/>
+          </a:xfrm>
+          <a:prstGeom prst="rect">
+            <a:avLst/>
+          </a:prstGeom>
+        </p:spPr>
+      </p:pic>
+      <p:sp>
+        <p:nvSpPr>
+          <p:cNvPr id="19" name="Text 12"/>
+          <p:cNvSpPr txBox="1"/>
+          <p:nvPr/>
+        </p:nvSpPr>
+        <p:spPr>
+          <a:xfrm>
+            <a:off x="1325880" y="4873752"/>
+            <a:ext cx="5760720" cy="310896"/>
+          </a:xfrm>
+          <a:prstGeom prst="rect">
+            <a:avLst/>
+          </a:prstGeom>
+          <a:noFill/>
+          <a:ln/>
+        </p:spPr>
+        <p:txBody>
+          <a:bodyPr wrap="square" lIns="0" tIns="0" rIns="0" bIns="0" rtlCol="0" anchor="t"/>
+          <a:lstStyle/>
+          <a:p>
+            <a:pPr marL="0" indent="0">
+              <a:buNone/>
+            </a:pPr>
+            <a:r>
+              <a:rPr lang="ko-KR" sz="1500" b="1" dirty="0">
+                <a:solidFill>
+                  <a:srgbClr val="151A21"/>
+                </a:solidFill>
+                <a:latin typeface="Arial" pitchFamily="34" charset="0"/>
+                <a:ea typeface="맑은 고딕" pitchFamily="34" charset="-122"/>
+                <a:cs typeface="Arial" pitchFamily="34" charset="-120"/>
+              </a:rPr>
+              <a:t>A High-Value Target</a:t>
+            </a:r>
+            <a:endParaRPr lang="en-US" sz="1500" dirty="0"/>
+          </a:p>
+        </p:txBody>
+      </p:sp>
+      <p:sp>
+        <p:nvSpPr>
+          <p:cNvPr id="20" name="Text 13"/>
+          <p:cNvSpPr txBox="1"/>
+          <p:nvPr/>
+        </p:nvSpPr>
+        <p:spPr>
+          <a:xfrm>
+            <a:off x="1325880" y="5221224"/>
+            <a:ext cx="5760720" cy="621792"/>
+          </a:xfrm>
+          <a:prstGeom prst="rect">
+            <a:avLst/>
+          </a:prstGeom>
+          <a:noFill/>
+          <a:ln/>
+        </p:spPr>
+        <p:txBody>
+          <a:bodyPr wrap="square" lIns="0" tIns="0" rIns="0" bIns="0" rtlCol="0" anchor="t"/>
+          <a:lstStyle/>
+          <a:p>
+            <a:pPr marL="0" indent="0">
+              <a:buNone/>
+            </a:pPr>
+            <a:r>
+              <a:rPr lang="ko-KR" sz="1200" dirty="0">
+                <a:solidFill>
+                  <a:srgbClr val="5E6978"/>
+                </a:solidFill>
+                <a:latin typeface="Calibri" pitchFamily="34" charset="0"/>
+                <a:ea typeface="맑은 고딕" pitchFamily="34" charset="-122"/>
+                <a:cs typeface="Calibri" pitchFamily="34" charset="-120"/>
+              </a:rPr>
+              <a:t>Hotels hold payment card data and guest identities — a frequent target for ransomware and data theft, with direct impact on brand trust.</a:t>
+            </a:r>
+            <a:endParaRPr lang="en-US" sz="1200" dirty="0"/>
+          </a:p>
+        </p:txBody>
+      </p:sp>
+      <p:sp>
+        <p:nvSpPr>
+          <p:cNvPr id="21" name="Shape 14"/>
+          <p:cNvSpPr/>
+          <p:nvPr/>
+        </p:nvSpPr>
+        <p:spPr>
+          <a:xfrm>
+            <a:off x="7452360" y="1554480"/>
+            <a:ext cx="4190695" cy="4434840"/>
+          </a:xfrm>
+          <a:prstGeom prst="roundRect">
+            <a:avLst>
+              <a:gd name="adj" fmla="val 2182"/>
+            </a:avLst>
+          </a:prstGeom>
+          <a:solidFill>
+            <a:srgbClr val="0B0D12"/>
+          </a:solidFill>
+          <a:ln w="12700">
+            <a:solidFill>
+              <a:srgbClr val="0B0D12"/>
+            </a:solidFill>
+            <a:prstDash val="solid"/>
+          </a:ln>
+        </p:spPr>
+      </p:sp>
+      <p:sp>
+        <p:nvSpPr>
+          <p:cNvPr id="22" name="Text 15"/>
+          <p:cNvSpPr txBox="1"/>
+          <p:nvPr/>
+        </p:nvSpPr>
+        <p:spPr>
+          <a:xfrm>
+            <a:off x="7818120" y="1828800"/>
+            <a:ext cx="3459175" cy="274320"/>
+          </a:xfrm>
+          <a:prstGeom prst="rect">
+            <a:avLst/>
+          </a:prstGeom>
+          <a:noFill/>
+          <a:ln/>
+        </p:spPr>
+        <p:txBody>
+          <a:bodyPr wrap="square" lIns="0" tIns="0" rIns="0" bIns="0" rtlCol="0" anchor="t"/>
+          <a:lstStyle/>
+          <a:p>
+            <a:pPr marL="0" indent="0">
+              <a:buNone/>
+            </a:pPr>
+            <a:r>
+              <a:rPr lang="ko-KR" sz="1100" b="1" kern="0" spc="200" dirty="0">
+                <a:solidFill>
+                  <a:srgbClr val="E3202A"/>
+                </a:solidFill>
+                <a:latin typeface="Calibri" pitchFamily="34" charset="0"/>
+                <a:ea typeface="맑은 고딕" pitchFamily="34" charset="-122"/>
+                <a:cs typeface="Calibri" pitchFamily="34" charset="-120"/>
+              </a:rPr>
+              <a:t>WHAT THE RESORT NEEDS</a:t>
+            </a:r>
+            <a:endParaRPr lang="en-US" sz="1100" dirty="0"/>
+          </a:p>
+        </p:txBody>
+      </p:sp>
+      <p:pic>
+        <p:nvPicPr>
+          <p:cNvPr id="23" name="Image 5" descr="preencoded.png"/>
+          <p:cNvPicPr>
+            <a:picLocks noChangeAspect="1"/>
+          </p:cNvPicPr>
+          <p:nvPr/>
+        </p:nvPicPr>
+        <p:blipFill>
+          <a:blip r:embed="rId8"/>
+          <a:stretch>
+            <a:fillRect/>
+          </a:stretch>
+        </p:blipFill>
+        <p:spPr>
+          <a:xfrm>
+            <a:off x="7818120" y="2322576"/>
+            <a:ext cx="237744" cy="237744"/>
+          </a:xfrm>
+          <a:prstGeom prst="rect">
+            <a:avLst/>
+          </a:prstGeom>
+        </p:spPr>
+      </p:pic>
+      <p:sp>
+        <p:nvSpPr>
+          <p:cNvPr id="24" name="Text 16"/>
+          <p:cNvSpPr txBox="1"/>
+          <p:nvPr/>
+        </p:nvSpPr>
+        <p:spPr>
+          <a:xfrm>
+            <a:off x="8183880" y="2286000"/>
+            <a:ext cx="3093415" cy="329184"/>
+          </a:xfrm>
+          <a:prstGeom prst="rect">
+            <a:avLst/>
+          </a:prstGeom>
+          <a:noFill/>
+          <a:ln/>
+        </p:spPr>
+        <p:txBody>
+          <a:bodyPr wrap="square" lIns="0" tIns="0" rIns="0" bIns="0" rtlCol="0" anchor="ctr"/>
+          <a:lstStyle/>
+          <a:p>
+            <a:pPr marL="0" indent="0">
+              <a:buNone/>
+            </a:pPr>
+            <a:r>
+              <a:rPr lang="ko-KR" sz="1300" dirty="0">
+                <a:solidFill>
+                  <a:srgbClr val="FFFFFF"/>
+                </a:solidFill>
+                <a:latin typeface="Calibri" pitchFamily="34" charset="0"/>
+                <a:ea typeface="맑은 고딕" pitchFamily="34" charset="-122"/>
+                <a:cs typeface="Calibri" pitchFamily="34" charset="-120"/>
+              </a:rPr>
+              <a:t>Automatic prevention of malware and ransomware</a:t>
+            </a:r>
+            <a:endParaRPr lang="en-US" sz="1300" dirty="0"/>
+          </a:p>
+        </p:txBody>
+      </p:sp>
+      <p:pic>
+        <p:nvPicPr>
+          <p:cNvPr id="25" name="Image 6" descr="preencoded.png"/>
+          <p:cNvPicPr>
+            <a:picLocks noChangeAspect="1"/>
+          </p:cNvPicPr>
+          <p:nvPr/>
+        </p:nvPicPr>
+        <p:blipFill>
+          <a:blip r:embed="rId8"/>
+          <a:stretch>
+            <a:fillRect/>
+          </a:stretch>
+        </p:blipFill>
+        <p:spPr>
+          <a:xfrm>
+            <a:off x="7818120" y="2852928"/>
+            <a:ext cx="237744" cy="237744"/>
+          </a:xfrm>
+          <a:prstGeom prst="rect">
+            <a:avLst/>
+          </a:prstGeom>
+        </p:spPr>
+      </p:pic>
+      <p:sp>
+        <p:nvSpPr>
+          <p:cNvPr id="26" name="Text 17"/>
+          <p:cNvSpPr txBox="1"/>
+          <p:nvPr/>
+        </p:nvSpPr>
+        <p:spPr>
+          <a:xfrm>
+            <a:off x="8183880" y="2816352"/>
+            <a:ext cx="3093415" cy="329184"/>
+          </a:xfrm>
+          <a:prstGeom prst="rect">
+            <a:avLst/>
+          </a:prstGeom>
+          <a:noFill/>
+          <a:ln/>
+        </p:spPr>
+        <p:txBody>
+          <a:bodyPr wrap="square" lIns="0" tIns="0" rIns="0" bIns="0" rtlCol="0" anchor="ctr"/>
+          <a:lstStyle/>
+          <a:p>
+            <a:pPr marL="0" indent="0">
+              <a:buNone/>
+            </a:pPr>
+            <a:r>
+              <a:rPr lang="ko-KR" sz="1300" dirty="0">
+                <a:solidFill>
+                  <a:srgbClr val="FFFFFF"/>
+                </a:solidFill>
+                <a:latin typeface="Calibri" pitchFamily="34" charset="0"/>
+                <a:ea typeface="맑은 고딕" pitchFamily="34" charset="-122"/>
+                <a:cs typeface="Calibri" pitchFamily="34" charset="-120"/>
+              </a:rPr>
+              <a:t>Real-time detection and containment of attacks</a:t>
+            </a:r>
+            <a:endParaRPr lang="en-US" sz="1300" dirty="0"/>
+          </a:p>
+        </p:txBody>
+      </p:sp>
+      <p:pic>
+        <p:nvPicPr>
+          <p:cNvPr id="27" name="Image 7" descr="preencoded.png"/>
+          <p:cNvPicPr>
+            <a:picLocks noChangeAspect="1"/>
+          </p:cNvPicPr>
+          <p:nvPr/>
+        </p:nvPicPr>
+        <p:blipFill>
+          <a:blip r:embed="rId8"/>
+          <a:stretch>
+            <a:fillRect/>
+          </a:stretch>
+        </p:blipFill>
+        <p:spPr>
+          <a:xfrm>
+            <a:off x="7818120" y="3383280"/>
+            <a:ext cx="237744" cy="237744"/>
+          </a:xfrm>
+          <a:prstGeom prst="rect">
+            <a:avLst/>
+          </a:prstGeom>
+        </p:spPr>
+      </p:pic>
+      <p:sp>
+        <p:nvSpPr>
+          <p:cNvPr id="28" name="Text 18"/>
+          <p:cNvSpPr txBox="1"/>
+          <p:nvPr/>
+        </p:nvSpPr>
+        <p:spPr>
+          <a:xfrm>
+            <a:off x="8183880" y="3346704"/>
+            <a:ext cx="3093415" cy="329184"/>
+          </a:xfrm>
+          <a:prstGeom prst="rect">
+            <a:avLst/>
+          </a:prstGeom>
+          <a:noFill/>
+          <a:ln/>
+        </p:spPr>
+        <p:txBody>
+          <a:bodyPr wrap="square" lIns="0" tIns="0" rIns="0" bIns="0" rtlCol="0" anchor="ctr"/>
+          <a:lstStyle/>
+          <a:p>
+            <a:pPr marL="0" indent="0">
+              <a:buNone/>
+            </a:pPr>
+            <a:r>
+              <a:rPr lang="ko-KR" sz="1300" dirty="0">
+                <a:solidFill>
+                  <a:srgbClr val="FFFFFF"/>
+                </a:solidFill>
+                <a:latin typeface="Calibri" pitchFamily="34" charset="0"/>
+                <a:ea typeface="맑은 고딕" pitchFamily="34" charset="-122"/>
+                <a:cs typeface="Calibri" pitchFamily="34" charset="-120"/>
+              </a:rPr>
+              <a:t>Low day-to-day workload for the IT team</a:t>
+            </a:r>
+            <a:endParaRPr lang="en-US" sz="1300" dirty="0"/>
+          </a:p>
+        </p:txBody>
+      </p:sp>
+      <p:pic>
+        <p:nvPicPr>
+          <p:cNvPr id="29" name="Image 8" descr="preencoded.png"/>
+          <p:cNvPicPr>
+            <a:picLocks noChangeAspect="1"/>
+          </p:cNvPicPr>
+          <p:nvPr/>
+        </p:nvPicPr>
+        <p:blipFill>
+          <a:blip r:embed="rId8"/>
+          <a:stretch>
+            <a:fillRect/>
+          </a:stretch>
+        </p:blipFill>
+        <p:spPr>
+          <a:xfrm>
+            <a:off x="7818120" y="3913632"/>
+            <a:ext cx="237744" cy="237744"/>
+          </a:xfrm>
+          <a:prstGeom prst="rect">
+            <a:avLst/>
+          </a:prstGeom>
+        </p:spPr>
+      </p:pic>
+      <p:sp>
+        <p:nvSpPr>
+          <p:cNvPr id="30" name="Text 19"/>
+          <p:cNvSpPr txBox="1"/>
+          <p:nvPr/>
+        </p:nvSpPr>
+        <p:spPr>
+          <a:xfrm>
+            <a:off x="8183880" y="3877056"/>
+            <a:ext cx="3093415" cy="329184"/>
+          </a:xfrm>
+          <a:prstGeom prst="rect">
+            <a:avLst/>
+          </a:prstGeom>
+          <a:noFill/>
+          <a:ln/>
+        </p:spPr>
+        <p:txBody>
+          <a:bodyPr wrap="square" lIns="0" tIns="0" rIns="0" bIns="0" rtlCol="0" anchor="ctr"/>
+          <a:lstStyle/>
+          <a:p>
+            <a:pPr marL="0" indent="0">
+              <a:buNone/>
+            </a:pPr>
+            <a:r>
+              <a:rPr lang="ko-KR" sz="1300" dirty="0">
+                <a:solidFill>
+                  <a:srgbClr val="FFFFFF"/>
+                </a:solidFill>
+                <a:latin typeface="Calibri" pitchFamily="34" charset="0"/>
+                <a:ea typeface="맑은 고딕" pitchFamily="34" charset="-122"/>
+                <a:cs typeface="Calibri" pitchFamily="34" charset="-120"/>
+              </a:rPr>
+              <a:t>Expert help available 24/7</a:t>
+            </a:r>
+            <a:endParaRPr lang="en-US" sz="1300" dirty="0"/>
+          </a:p>
+        </p:txBody>
+      </p:sp>
+      <p:pic>
+        <p:nvPicPr>
+          <p:cNvPr id="31" name="Image 9" descr="preencoded.png"/>
+          <p:cNvPicPr>
+            <a:picLocks noChangeAspect="1"/>
+          </p:cNvPicPr>
+          <p:nvPr/>
+        </p:nvPicPr>
+        <p:blipFill>
+          <a:blip r:embed="rId8"/>
+          <a:stretch>
+            <a:fillRect/>
+          </a:stretch>
+        </p:blipFill>
+        <p:spPr>
+          <a:xfrm>
+            <a:off x="7818120" y="4443984"/>
+            <a:ext cx="237744" cy="237744"/>
+          </a:xfrm>
+          <a:prstGeom prst="rect">
+            <a:avLst/>
+          </a:prstGeom>
+        </p:spPr>
+      </p:pic>
+      <p:sp>
+        <p:nvSpPr>
+          <p:cNvPr id="32" name="Text 20"/>
+          <p:cNvSpPr txBox="1"/>
+          <p:nvPr/>
+        </p:nvSpPr>
+        <p:spPr>
+          <a:xfrm>
+            <a:off x="8183880" y="4407408"/>
+            <a:ext cx="3093415" cy="329184"/>
+          </a:xfrm>
+          <a:prstGeom prst="rect">
+            <a:avLst/>
+          </a:prstGeom>
+          <a:noFill/>
+          <a:ln/>
+        </p:spPr>
+        <p:txBody>
+          <a:bodyPr wrap="square" lIns="0" tIns="0" rIns="0" bIns="0" rtlCol="0" anchor="ctr"/>
+          <a:lstStyle/>
+          <a:p>
+            <a:pPr marL="0" indent="0">
+              <a:buNone/>
+            </a:pPr>
+            <a:r>
+              <a:rPr lang="ko-KR" sz="1300" dirty="0">
+                <a:solidFill>
+                  <a:srgbClr val="FFFFFF"/>
+                </a:solidFill>
+                <a:latin typeface="Calibri" pitchFamily="34" charset="0"/>
+                <a:ea typeface="맑은 고딕" pitchFamily="34" charset="-122"/>
+                <a:cs typeface="Calibri" pitchFamily="34" charset="-120"/>
+              </a:rPr>
+              <a:t>Clear reporting for management and audits</a:t>
+            </a:r>
+            <a:endParaRPr lang="en-US" sz="1300" dirty="0"/>
+          </a:p>
+        </p:txBody>
+      </p:sp>
+      <p:sp>
+        <p:nvSpPr>
+          <p:cNvPr id="33" name="Text 21"/>
+          <p:cNvSpPr txBox="1"/>
+          <p:nvPr/>
+        </p:nvSpPr>
+        <p:spPr>
+          <a:xfrm>
+            <a:off x="7818120" y="5120640"/>
+            <a:ext cx="3459175" cy="548640"/>
+          </a:xfrm>
+          <a:prstGeom prst="rect">
+            <a:avLst/>
+          </a:prstGeom>
+          <a:noFill/>
+          <a:ln/>
+        </p:spPr>
+        <p:txBody>
+          <a:bodyPr wrap="square" lIns="0" tIns="0" rIns="0" bIns="0" rtlCol="0" anchor="ctr"/>
+          <a:lstStyle/>
+          <a:p>
+            <a:pPr marL="0" indent="0">
+              <a:buNone/>
+            </a:pPr>
+            <a:r>
+              <a:rPr lang="ko-KR" sz="1400" b="1" i="1" dirty="0">
+                <a:solidFill>
+                  <a:srgbClr val="FFFFFF"/>
+                </a:solidFill>
+                <a:latin typeface="Calibri" pitchFamily="34" charset="0"/>
+                <a:ea typeface="맑은 고딕" pitchFamily="34" charset="-122"/>
+                <a:cs typeface="Calibri" pitchFamily="34" charset="-120"/>
+              </a:rPr>
+              <a:t>The goal is not more reports — it is fewer incidents.</a:t>
+            </a:r>
+            <a:endParaRPr lang="en-US" sz="1400" dirty="0"/>
+          </a:p>
+        </p:txBody>
+      </p:sp>
+      <p:sp>
+        <p:nvSpPr>
+          <p:cNvPr id="34" name="Text 22"/>
+          <p:cNvSpPr txBox="1"/>
+          <p:nvPr/>
+        </p:nvSpPr>
+        <p:spPr>
+          <a:xfrm>
+            <a:off x="548640" y="6446520"/>
+            <a:ext cx="7315200" cy="219456"/>
+          </a:xfrm>
+          <a:prstGeom prst="rect">
+            <a:avLst/>
+          </a:prstGeom>
+          <a:noFill/>
+          <a:ln/>
+        </p:spPr>
+        <p:txBody>
+          <a:bodyPr wrap="square" lIns="0" tIns="0" rIns="0" bIns="0" rtlCol="0" anchor="ctr"/>
+          <a:lstStyle/>
+          <a:p>
+            <a:pPr marL="0" indent="0">
+              <a:buNone/>
+            </a:pPr>
+            <a:r>
+              <a:rPr lang="ko-KR" sz="900" dirty="0">
+                <a:solidFill>
+                  <a:srgbClr val="5E6978"/>
+                </a:solidFill>
+                <a:latin typeface="Calibri" pitchFamily="34" charset="0"/>
+                <a:ea typeface="맑은 고딕" pitchFamily="34" charset="-122"/>
+                <a:cs typeface="Calibri" pitchFamily="34" charset="-120"/>
+              </a:rPr>
+              <a:t>02   |   CrowdStrike Falcon Proposal  ·  The Westin Resort Guam</a:t>
+            </a:r>
+            <a:endParaRPr lang="en-US" sz="900" dirty="0"/>
+          </a:p>
+        </p:txBody>
+      </p:sp>
+      <p:pic>
+        <p:nvPicPr>
+          <p:cNvPr id="35" name="Image 10" descr="/private/tmp/claude-501/-Users-jihanvin-Desktop-NIVNAH-AI/16a96446-d9b3-40e2-af9e-a3011ae3db84/scratchpad/assets/secukorea_dark.png"/>
+          <p:cNvPicPr>
+            <a:picLocks noChangeAspect="1"/>
+          </p:cNvPicPr>
+          <p:nvPr/>
+        </p:nvPicPr>
+        <p:blipFill>
+          <a:blip r:embed="rId9"/>
+          <a:stretch>
+            <a:fillRect/>
+          </a:stretch>
+        </p:blipFill>
+        <p:spPr>
+          <a:xfrm>
+            <a:off x="10661904" y="6400800"/>
+            <a:ext cx="978408" cy="233172"/>
+          </a:xfrm>
+          <a:prstGeom prst="rect">
+            <a:avLst/>
+          </a:prstGeom>
+        </p:spPr>
+      </p:pic>
+    </p:spTree>
+  </p:cSld>
+  <p:clrMapOvr>
+    <a:masterClrMapping/>
+  </p:clrMapOvr>
+</p:sld>
+</file>
+
+<file path=ppt/slides/slide3.xml><?xml version="1.0" encoding="utf-8"?>
 <p:sld xmlns:a="http://schemas.openxmlformats.org/drawingml/2006/main" xmlns:r="http://schemas.openxmlformats.org/officeDocument/2006/relationships" xmlns:p="http://schemas.openxmlformats.org/presentationml/2006/main">
   <p:cSld name="Slide 4">
     <p:bg>
@@ -1852,7 +3022,7 @@
                 <a:ea typeface="Arial" pitchFamily="34" charset="-122"/>
                 <a:cs typeface="Arial" pitchFamily="34" charset="-120"/>
               </a:rPr>
-              <a:t>01   SECURITY TRENDS</a:t>
+              <a:t>02   SECURITY TRENDS</a:t>
             </a:r>
             <a:endParaRPr lang="en-US" sz="1100" dirty="0"/>
           </a:p>
@@ -2020,7 +3190,7 @@
                 <a:ea typeface="Calibri" pitchFamily="34" charset="-122"/>
                 <a:cs typeface="Calibri" pitchFamily="34" charset="-120"/>
               </a:rPr>
-              <a:t>Fastest time for hackers to spread from one PC to other systems</a:t>
+              <a:t>Fastest recorded time for hackers to spread from one PC to other systems (average: 29 min)</a:t>
             </a:r>
             <a:endParaRPr lang="en-US" sz="1200" dirty="0"/>
           </a:p>
@@ -2125,7 +3295,7 @@
                 <a:ea typeface="Calibri" pitchFamily="34" charset="-122"/>
                 <a:cs typeface="Calibri" pitchFamily="34" charset="-120"/>
               </a:rPr>
-              <a:t>Increase in attacks by hackers using AI (2025)</a:t>
+              <a:t>Year-over-year increase in attacks by hackers using AI (2025)</a:t>
             </a:r>
             <a:endParaRPr lang="en-US" sz="1200" dirty="0"/>
           </a:p>
@@ -2230,7 +3400,7 @@
                 <a:ea typeface="Calibri" pitchFamily="34" charset="-122"/>
                 <a:cs typeface="Calibri" pitchFamily="34" charset="-120"/>
               </a:rPr>
-              <a:t>Increase in attacks on security holes no one knew about yet</a:t>
+              <a:t>Year-over-year increase in attacks on security holes before they were made public (zero-days)</a:t>
             </a:r>
             <a:endParaRPr lang="en-US" sz="1200" dirty="0"/>
           </a:p>
@@ -2335,7 +3505,7 @@
                 <a:ea typeface="Calibri" pitchFamily="34" charset="-122"/>
                 <a:cs typeface="Calibri" pitchFamily="34" charset="-120"/>
               </a:rPr>
-              <a:t>Of organizations were hit by ransomware in the past year</a:t>
+              <a:t>Of 1,100 organizations surveyed were hit by ransomware in the past year</a:t>
             </a:r>
             <a:endParaRPr lang="en-US" sz="1200" dirty="0"/>
           </a:p>
@@ -2800,7 +3970,7 @@
                 <a:ea typeface="Calibri" pitchFamily="34" charset="-122"/>
                 <a:cs typeface="Calibri" pitchFamily="34" charset="-120"/>
               </a:rPr>
-              <a:t>Sources: CrowdStrike 2026 Global Threat Report; CrowdStrike State of Ransomware Survey.</a:t>
+              <a:t>Sources: CrowdStrike 2026 Global Threat Report (2025 data); CrowdStrike 2025 State of Ransomware Survey (1,100 security leaders).</a:t>
             </a:r>
             <a:endParaRPr lang="en-US" sz="800" dirty="0"/>
           </a:p>
@@ -2839,7 +4009,7 @@
                 <a:ea typeface="Calibri" pitchFamily="34" charset="-122"/>
                 <a:cs typeface="Calibri" pitchFamily="34" charset="-120"/>
               </a:rPr>
-              <a:t>02   |   CrowdStrike Falcon Proposal  ·  The Westin Resort Guam</a:t>
+              <a:t>03   |   CrowdStrike Falcon Proposal  ·  The Westin Resort Guam</a:t>
             </a:r>
             <a:endParaRPr lang="en-US" sz="900" dirty="0"/>
           </a:p>
@@ -2877,7 +4047,7 @@
 </p:sld>
 </file>
 
-<file path=ppt/slides/slide3.xml><?xml version="1.0" encoding="utf-8"?>
+<file path=ppt/slides/slide4.xml><?xml version="1.0" encoding="utf-8"?>
 <p:sld xmlns:a="http://schemas.openxmlformats.org/drawingml/2006/main" xmlns:r="http://schemas.openxmlformats.org/officeDocument/2006/relationships" xmlns:p="http://schemas.openxmlformats.org/presentationml/2006/main">
   <p:cSld name="Slide 6">
     <p:bg>
@@ -2935,7 +4105,7 @@
                 <a:ea typeface="Arial" pitchFamily="34" charset="-122"/>
                 <a:cs typeface="Arial" pitchFamily="34" charset="-120"/>
               </a:rPr>
-              <a:t>02   A SIMPLE WAY TO SEE IT</a:t>
+              <a:t>03   A SIMPLE WAY TO SEE IT</a:t>
             </a:r>
             <a:endParaRPr lang="en-US" sz="1100" dirty="0"/>
           </a:p>
@@ -3579,7 +4749,47 @@
               </a:rPr>
               <a:t>Sensors on every endpoint spot danger the moment it appears, stop it automatically, and escalate to experts who are on duty around the clock.</a:t>
             </a:r>
-            <a:endParaRPr lang="en-US" sz="1250" dirty="0"/>
+            <a:r>
+              <a:rPr lang="en-US" sz="1250" dirty="0" err="1">
+                <a:solidFill>
+                  <a:srgbClr val="5E6978"/>
+                </a:solidFill>
+                <a:latin typeface="Calibri" pitchFamily="34" charset="0"/>
+                <a:ea typeface="Calibri" pitchFamily="34" charset="-122"/>
+                <a:cs typeface="Calibri" pitchFamily="34" charset="-120"/>
+              </a:rPr>
+              <a:t/>
+            </a:r>
+            <a:r>
+              <a:rPr lang="en-US" sz="1250" dirty="0">
+                <a:solidFill>
+                  <a:srgbClr val="5E6978"/>
+                </a:solidFill>
+                <a:latin typeface="Calibri" pitchFamily="34" charset="0"/>
+                <a:ea typeface="Calibri" pitchFamily="34" charset="-122"/>
+                <a:cs typeface="Calibri" pitchFamily="34" charset="-120"/>
+              </a:rPr>
+              <a:t/>
+            </a:r>
+            <a:r>
+              <a:rPr lang="en-US" sz="1250" dirty="0" err="1">
+                <a:solidFill>
+                  <a:srgbClr val="5E6978"/>
+                </a:solidFill>
+                <a:latin typeface="Calibri" pitchFamily="34" charset="0"/>
+                <a:ea typeface="Calibri" pitchFamily="34" charset="-122"/>
+                <a:cs typeface="Calibri" pitchFamily="34" charset="-120"/>
+              </a:rPr>
+              <a:t/>
+            </a:r>
+            <a:endParaRPr lang="en-US" sz="1250" dirty="0">
+              <a:solidFill>
+                <a:srgbClr val="5E6978"/>
+              </a:solidFill>
+              <a:latin typeface="Calibri" pitchFamily="34" charset="0"/>
+              <a:ea typeface="Calibri" pitchFamily="34" charset="-122"/>
+              <a:cs typeface="Calibri" pitchFamily="34" charset="-120"/>
+            </a:endParaRPr>
           </a:p>
         </p:txBody>
       </p:sp>
@@ -3857,7 +5067,7 @@
           <a:bodyPr wrap="square" lIns="0" tIns="0" rIns="0" bIns="0" rtlCol="0" anchor="ctr"/>
           <a:lstStyle/>
           <a:p>
-            <a:pPr algn="ctr" marL="0" indent="0">
+            <a:pPr marL="0" indent="0" algn="ctr">
               <a:buNone/>
             </a:pPr>
             <a:r>
@@ -3880,21 +5090,21 @@
                 <a:ea typeface="Calibri" pitchFamily="34" charset="-122"/>
                 <a:cs typeface="Calibri" pitchFamily="34" charset="-120"/>
               </a:rPr>
-              <a:t> tells you what is wrong.  </a:t>
-            </a:r>
-            <a:r>
-              <a:rPr lang="en-US" sz="1600" b="1" dirty="0">
-                <a:solidFill>
-                  <a:srgbClr val="E3202A"/>
+              <a:t> only tells you what is wrong.  </a:t>
+            </a:r>
+            <a:r>
+              <a:rPr lang="en-US" sz="1600">
+                <a:solidFill>
+                  <a:srgbClr val="5E6978"/>
                 </a:solidFill>
                 <a:latin typeface="Calibri" pitchFamily="34" charset="0"/>
                 <a:ea typeface="Calibri" pitchFamily="34" charset="-122"/>
                 <a:cs typeface="Calibri" pitchFamily="34" charset="-120"/>
               </a:rPr>
-              <a:t>Falcon</a:t>
-            </a:r>
-            <a:r>
-              <a:rPr lang="en-US" sz="1600" dirty="0">
+              <a:t/>
+            </a:r>
+            <a:r>
+              <a:rPr lang="ko-KR" altLang="en-US" sz="1600">
                 <a:solidFill>
                   <a:srgbClr val="5E6978"/>
                 </a:solidFill>
@@ -3902,38 +5112,10 @@
                 <a:ea typeface="Calibri" pitchFamily="34" charset="-122"/>
                 <a:cs typeface="Calibri" pitchFamily="34" charset="-120"/>
               </a:rPr>
-              <a:t> stops the attack — around the clock.</a:t>
-            </a:r>
-            <a:endParaRPr lang="en-US" sz="1600" dirty="0"/>
-          </a:p>
-        </p:txBody>
-      </p:sp>
-      <p:sp>
-        <p:nvSpPr>
-          <p:cNvPr id="43" name="Text 32"/>
-          <p:cNvSpPr txBox="1"/>
-          <p:nvPr/>
-        </p:nvSpPr>
-        <p:spPr>
-          <a:xfrm>
-            <a:off x="548640" y="6446520"/>
-            <a:ext cx="7315200" cy="219456"/>
-          </a:xfrm>
-          <a:prstGeom prst="rect">
-            <a:avLst/>
-          </a:prstGeom>
-          <a:noFill/>
-          <a:ln/>
-        </p:spPr>
-        <p:txBody>
-          <a:bodyPr wrap="square" lIns="0" tIns="0" rIns="0" bIns="0" rtlCol="0" anchor="ctr"/>
-          <a:lstStyle/>
-          <a:p>
-            <a:pPr marL="0" indent="0">
-              <a:buNone/>
-            </a:pPr>
-            <a:r>
-              <a:rPr lang="en-US" sz="900" dirty="0">
+              <a:t/>
+            </a:r>
+            <a:r>
+              <a:rPr lang="en-US" sz="1600">
                 <a:solidFill>
                   <a:srgbClr val="5E6978"/>
                 </a:solidFill>
@@ -3941,7 +5123,79 @@
                 <a:ea typeface="Calibri" pitchFamily="34" charset="-122"/>
                 <a:cs typeface="Calibri" pitchFamily="34" charset="-120"/>
               </a:rPr>
-              <a:t>03   |   CrowdStrike Falcon Proposal  ·  The Westin Resort Guam</a:t>
+              <a:t/>
+            </a:r>
+            <a:r>
+              <a:rPr lang="en-US" sz="1600" dirty="0">
+                <a:solidFill>
+                  <a:srgbClr val="5E6978"/>
+                </a:solidFill>
+                <a:latin typeface="Calibri" pitchFamily="34" charset="0"/>
+                <a:ea typeface="Calibri" pitchFamily="34" charset="-122"/>
+                <a:cs typeface="Calibri" pitchFamily="34" charset="-120"/>
+              </a:rPr>
+              <a:t/>
+            </a:r>
+            <a:r>
+              <a:rPr lang="en-US" sz="1600" b="1" dirty="0">
+                <a:solidFill>
+                  <a:srgbClr val="E3202A"/>
+                </a:solidFill>
+                <a:latin typeface="Calibri" pitchFamily="34" charset="0"/>
+                <a:ea typeface="Calibri" pitchFamily="34" charset="-122"/>
+                <a:cs typeface="Calibri" pitchFamily="34" charset="-120"/>
+              </a:rPr>
+              <a:t>Falcon</a:t>
+            </a:r>
+            <a:r>
+              <a:rPr lang="en-US" sz="1600" dirty="0">
+                <a:solidFill>
+                  <a:srgbClr val="5E6978"/>
+                </a:solidFill>
+                <a:latin typeface="Calibri" pitchFamily="34" charset="0"/>
+                <a:ea typeface="Calibri" pitchFamily="34" charset="-122"/>
+                <a:cs typeface="Calibri" pitchFamily="34" charset="-120"/>
+              </a:rPr>
+              <a:t> stops the attack — around the clock.</a:t>
+            </a:r>
+            <a:endParaRPr lang="en-US" sz="1600" dirty="0"/>
+          </a:p>
+        </p:txBody>
+      </p:sp>
+      <p:sp>
+        <p:nvSpPr>
+          <p:cNvPr id="43" name="Text 32"/>
+          <p:cNvSpPr txBox="1"/>
+          <p:nvPr/>
+        </p:nvSpPr>
+        <p:spPr>
+          <a:xfrm>
+            <a:off x="548640" y="6446520"/>
+            <a:ext cx="7315200" cy="219456"/>
+          </a:xfrm>
+          <a:prstGeom prst="rect">
+            <a:avLst/>
+          </a:prstGeom>
+          <a:noFill/>
+          <a:ln/>
+        </p:spPr>
+        <p:txBody>
+          <a:bodyPr wrap="square" lIns="0" tIns="0" rIns="0" bIns="0" rtlCol="0" anchor="ctr"/>
+          <a:lstStyle/>
+          <a:p>
+            <a:pPr marL="0" indent="0">
+              <a:buNone/>
+            </a:pPr>
+            <a:r>
+              <a:rPr lang="en-US" sz="900" dirty="0">
+                <a:solidFill>
+                  <a:srgbClr val="5E6978"/>
+                </a:solidFill>
+                <a:latin typeface="Calibri" pitchFamily="34" charset="0"/>
+                <a:ea typeface="Calibri" pitchFamily="34" charset="-122"/>
+                <a:cs typeface="Calibri" pitchFamily="34" charset="-120"/>
+              </a:rPr>
+              <a:t>04   |   CrowdStrike Falcon Proposal  ·  The Westin Resort Guam</a:t>
             </a:r>
             <a:endParaRPr lang="en-US" sz="900" dirty="0"/>
           </a:p>
@@ -3979,7 +5233,7 @@
 </p:sld>
 </file>
 
-<file path=ppt/slides/slide4.xml><?xml version="1.0" encoding="utf-8"?>
+<file path=ppt/slides/slide5.xml><?xml version="1.0" encoding="utf-8"?>
 <p:sld xmlns:a="http://schemas.openxmlformats.org/drawingml/2006/main" xmlns:r="http://schemas.openxmlformats.org/officeDocument/2006/relationships" xmlns:p="http://schemas.openxmlformats.org/presentationml/2006/main">
   <p:cSld name="Slide 13">
     <p:bg>
@@ -4029,7 +5283,7 @@
               <a:buNone/>
             </a:pPr>
             <a:r>
-              <a:rPr lang="en-US" sz="1350" b="1" kern="0" spc="200" dirty="0">
+              <a:rPr lang="en-US" sz="1100" b="1" kern="0" spc="200" dirty="0">
                 <a:solidFill>
                   <a:srgbClr val="E3202A"/>
                 </a:solidFill>
@@ -4037,9 +5291,9 @@
                 <a:ea typeface="Arial" pitchFamily="34" charset="-122"/>
                 <a:cs typeface="Arial" pitchFamily="34" charset="-120"/>
               </a:rPr>
-              <a:t>03   COMPARISON</a:t>
-            </a:r>
-            <a:endParaRPr lang="en-US" sz="1350" dirty="0"/>
+              <a:t>04   COMPARISON</a:t>
+            </a:r>
+            <a:endParaRPr lang="en-US" sz="1100" dirty="0"/>
           </a:p>
         </p:txBody>
       </p:sp>
@@ -4122,7 +5376,7 @@
         </p:nvGraphicFramePr>
         <p:xfrm>
           <a:off x="548640" y="1481328"/>
-          <a:ext cx="11094415" cy="4526280"/>
+          <a:ext cx="11094415" cy="4526277"/>
         </p:xfrm>
         <a:graphic>
           <a:graphicData uri="http://schemas.openxmlformats.org/drawingml/2006/table">
@@ -5695,7 +6949,7 @@
                 <a:ea typeface="Calibri" pitchFamily="34" charset="-122"/>
                 <a:cs typeface="Calibri" pitchFamily="34" charset="-120"/>
               </a:rPr>
-              <a:t>04   |   CrowdStrike Falcon Proposal  ·  The Westin Resort Guam</a:t>
+              <a:t>05   |   CrowdStrike Falcon Proposal  ·  The Westin Resort Guam</a:t>
             </a:r>
             <a:endParaRPr lang="en-US" sz="900" dirty="0"/>
           </a:p>
@@ -5733,7 +6987,7 @@
 </p:sld>
 </file>
 
-<file path=ppt/slides/slide5.xml><?xml version="1.0" encoding="utf-8"?>
+<file path=ppt/slides/slide6.xml><?xml version="1.0" encoding="utf-8"?>
 <p:sld xmlns:a="http://schemas.openxmlformats.org/drawingml/2006/main" xmlns:r="http://schemas.openxmlformats.org/officeDocument/2006/relationships" xmlns:p="http://schemas.openxmlformats.org/presentationml/2006/main">
   <p:cSld name="Slide 18">
     <p:bg>
@@ -5791,7 +7045,7 @@
                 <a:ea typeface="Arial" pitchFamily="34" charset="-122"/>
                 <a:cs typeface="Arial" pitchFamily="34" charset="-120"/>
               </a:rPr>
-              <a:t>04   EXPECTED BENEFITS</a:t>
+              <a:t>05   EXPECTED BENEFITS</a:t>
             </a:r>
             <a:endParaRPr lang="en-US" sz="1100" dirty="0"/>
           </a:p>
@@ -7331,7 +8585,7 @@
                 <a:ea typeface="Calibri" pitchFamily="34" charset="-122"/>
                 <a:cs typeface="Calibri" pitchFamily="34" charset="-120"/>
               </a:rPr>
-              <a:t>05   |   CrowdStrike Falcon Proposal  ·  The Westin Resort Guam</a:t>
+              <a:t>06   |   CrowdStrike Falcon Proposal  ·  The Westin Resort Guam</a:t>
             </a:r>
             <a:endParaRPr lang="en-US" sz="900" dirty="0"/>
           </a:p>
@@ -7378,7 +8632,7 @@
           <a:noFill/>
         </p:spPr>
         <p:txBody>
-          <a:bodyPr wrap="square" lIns="0" rIns="0" tIns="0" bIns="0" anchor="t">
+          <a:bodyPr wrap="square" lIns="0" tIns="0" rIns="0" bIns="0" anchor="t">
             <a:spAutoFit/>
           </a:bodyPr>
           <a:lstStyle/>
@@ -7390,6 +8644,7 @@
                   <a:srgbClr val="E3202A"/>
                 </a:solidFill>
                 <a:latin typeface="Calibri"/>
+                <a:ea typeface="Malgun Gothic"/>
               </a:rPr>
               <a:t>Proposal scope:  </a:t>
             </a:r>
@@ -7399,2116 +8654,9 @@
                   <a:srgbClr val="5E6978"/>
                 </a:solidFill>
                 <a:latin typeface="Calibri"/>
+                <a:ea typeface="Malgun Gothic"/>
               </a:rPr>
               <a:t>Falcon Prevent (next-gen antivirus) + Falcon Insight (detection &amp; response), with SECUKOREA 24/7 technical support.</a:t>
-            </a:r>
-          </a:p>
-        </p:txBody>
-      </p:sp>
-    </p:spTree>
-  </p:cSld>
-  <p:clrMapOvr>
-    <a:masterClrMapping/>
-  </p:clrMapOvr>
-</p:sld>
-</file>
-
-<file path=ppt/slides/slide6.xml><?xml version="1.0" encoding="utf-8"?>
-<p:sld xmlns:a="http://schemas.openxmlformats.org/drawingml/2006/main" xmlns:r="http://schemas.openxmlformats.org/officeDocument/2006/relationships" xmlns:p="http://schemas.openxmlformats.org/presentationml/2006/main">
-  <p:cSld name="Slide 15">
-    <p:bg>
-      <p:bgPr>
-        <a:solidFill>
-          <a:srgbClr val="FFFFFF"/>
-        </a:solidFill>
-        <a:effectLst/>
-      </p:bgPr>
-    </p:bg>
-    <p:spTree>
-      <p:nvGrpSpPr>
-        <p:cNvPr id="1" name=""/>
-        <p:cNvGrpSpPr/>
-        <p:nvPr/>
-      </p:nvGrpSpPr>
-      <p:grpSpPr>
-        <a:xfrm>
-          <a:off x="0" y="0"/>
-          <a:ext cx="0" cy="0"/>
-          <a:chOff x="0" y="0"/>
-          <a:chExt cx="0" cy="0"/>
-        </a:xfrm>
-      </p:grpSpPr>
-      <p:sp>
-        <p:nvSpPr>
-          <p:cNvPr id="2" name="Text 0"/>
-          <p:cNvSpPr txBox="1"/>
-          <p:nvPr/>
-        </p:nvSpPr>
-        <p:spPr>
-          <a:xfrm>
-            <a:off x="548640" y="384048"/>
-            <a:ext cx="8229600" cy="256032"/>
-          </a:xfrm>
-          <a:prstGeom prst="rect">
-            <a:avLst/>
-          </a:prstGeom>
-          <a:noFill/>
-          <a:ln/>
-        </p:spPr>
-        <p:txBody>
-          <a:bodyPr wrap="square" lIns="0" tIns="0" rIns="0" bIns="0" rtlCol="0" anchor="t"/>
-          <a:lstStyle/>
-          <a:p>
-            <a:pPr marL="0" indent="0">
-              <a:buNone/>
-            </a:pPr>
-            <a:r>
-              <a:rPr lang="en-US" sz="1100" b="1" kern="0" spc="200" dirty="0">
-                <a:solidFill>
-                  <a:srgbClr val="E3202A"/>
-                </a:solidFill>
-                <a:latin typeface="Arial" pitchFamily="34" charset="0"/>
-                <a:ea typeface="Arial" pitchFamily="34" charset="-122"/>
-                <a:cs typeface="Arial" pitchFamily="34" charset="-120"/>
-              </a:rPr>
-              <a:t>05   PROVEN RESULTS</a:t>
-            </a:r>
-            <a:endParaRPr lang="en-US" sz="1100" dirty="0"/>
-          </a:p>
-        </p:txBody>
-      </p:sp>
-      <p:sp>
-        <p:nvSpPr>
-          <p:cNvPr id="3" name="Text 1"/>
-          <p:cNvSpPr txBox="1"/>
-          <p:nvPr/>
-        </p:nvSpPr>
-        <p:spPr>
-          <a:xfrm>
-            <a:off x="548640" y="658368"/>
-            <a:ext cx="9692640" cy="658368"/>
-          </a:xfrm>
-          <a:prstGeom prst="rect">
-            <a:avLst/>
-          </a:prstGeom>
-          <a:noFill/>
-          <a:ln/>
-        </p:spPr>
-        <p:txBody>
-          <a:bodyPr wrap="square" lIns="0" tIns="0" rIns="0" bIns="0" rtlCol="0" anchor="ctr"/>
-          <a:lstStyle/>
-          <a:p>
-            <a:pPr marL="0" indent="0">
-              <a:buNone/>
-            </a:pPr>
-            <a:r>
-              <a:rPr lang="en-US" sz="2800" b="1" dirty="0">
-                <a:solidFill>
-                  <a:srgbClr val="151A21"/>
-                </a:solidFill>
-                <a:latin typeface="Arial" pitchFamily="34" charset="0"/>
-                <a:ea typeface="Arial" pitchFamily="34" charset="-122"/>
-                <a:cs typeface="Arial" pitchFamily="34" charset="-120"/>
-              </a:rPr>
-              <a:t>Proven in Real Attacks and by Real Customers</a:t>
-            </a:r>
-            <a:endParaRPr lang="en-US" sz="2800" dirty="0"/>
-          </a:p>
-        </p:txBody>
-      </p:sp>
-      <p:pic>
-        <p:nvPicPr>
-          <p:cNvPr id="4" name="Image 0" descr="/private/tmp/claude-501/-Users-jihanvin-Desktop-NIVNAH-AI/16a96446-d9b3-40e2-af9e-a3011ae3db84/scratchpad/assets/westin_grey.png"/>
-          <p:cNvPicPr>
-            <a:picLocks noChangeAspect="1"/>
-          </p:cNvPicPr>
-          <p:nvPr/>
-        </p:nvPicPr>
-        <p:blipFill>
-          <a:blip r:embed="rId3"/>
-          <a:stretch>
-            <a:fillRect/>
-          </a:stretch>
-        </p:blipFill>
-        <p:spPr>
-          <a:xfrm>
-            <a:off x="10634472" y="402336"/>
-            <a:ext cx="1005840" cy="301752"/>
-          </a:xfrm>
-          <a:prstGeom prst="rect">
-            <a:avLst/>
-          </a:prstGeom>
-        </p:spPr>
-      </p:pic>
-      <p:sp>
-        <p:nvSpPr>
-          <p:cNvPr id="5" name="Shape 2"/>
-          <p:cNvSpPr/>
-          <p:nvPr/>
-        </p:nvSpPr>
-        <p:spPr>
-          <a:xfrm>
-            <a:off x="548640" y="3080000"/>
-            <a:ext cx="3515258" cy="1900000"/>
-          </a:xfrm>
-          <a:prstGeom prst="roundRect">
-            <a:avLst>
-              <a:gd name="adj" fmla="val 2601"/>
-            </a:avLst>
-          </a:prstGeom>
-          <a:solidFill>
-            <a:srgbClr val="FDECEC"/>
-          </a:solidFill>
-          <a:ln w="9525">
-            <a:solidFill>
-              <a:srgbClr val="F6C9CB"/>
-            </a:solidFill>
-            <a:prstDash val="solid"/>
-          </a:ln>
-        </p:spPr>
-      </p:sp>
-      <p:sp>
-        <p:nvSpPr>
-          <p:cNvPr id="6" name="Shape 3"/>
-          <p:cNvSpPr/>
-          <p:nvPr/>
-        </p:nvSpPr>
-        <p:spPr>
-          <a:xfrm>
-            <a:off x="868680" y="3240000"/>
-            <a:ext cx="457200" cy="457200"/>
-          </a:xfrm>
-          <a:prstGeom prst="roundRect">
-            <a:avLst>
-              <a:gd name="adj" fmla="val 16667"/>
-            </a:avLst>
-          </a:prstGeom>
-          <a:solidFill>
-            <a:srgbClr val="E3202A"/>
-          </a:solidFill>
-          <a:ln w="12700">
-            <a:solidFill>
-              <a:srgbClr val="E3202A"/>
-            </a:solidFill>
-            <a:prstDash val="solid"/>
-          </a:ln>
-        </p:spPr>
-      </p:sp>
-      <p:pic>
-        <p:nvPicPr>
-          <p:cNvPr id="7" name="Image 1" descr="preencoded.png"/>
-          <p:cNvPicPr>
-            <a:picLocks noChangeAspect="1"/>
-          </p:cNvPicPr>
-          <p:nvPr/>
-        </p:nvPicPr>
-        <p:blipFill>
-          <a:blip r:embed="rId4"/>
-          <a:stretch>
-            <a:fillRect/>
-          </a:stretch>
-        </p:blipFill>
-        <p:spPr>
-          <a:xfrm>
-            <a:off x="943680" y="3315000"/>
-            <a:ext cx="307238" cy="307238"/>
-          </a:xfrm>
-          <a:prstGeom prst="rect">
-            <a:avLst/>
-          </a:prstGeom>
-        </p:spPr>
-      </p:pic>
-      <p:sp>
-        <p:nvSpPr>
-          <p:cNvPr id="8" name="Text 4"/>
-          <p:cNvSpPr txBox="1"/>
-          <p:nvPr/>
-        </p:nvSpPr>
-        <p:spPr>
-          <a:xfrm>
-            <a:off x="1468680" y="3245000"/>
-            <a:ext cx="2235098" cy="237744"/>
-          </a:xfrm>
-          <a:prstGeom prst="rect">
-            <a:avLst/>
-          </a:prstGeom>
-          <a:noFill/>
-          <a:ln/>
-        </p:spPr>
-        <p:txBody>
-          <a:bodyPr wrap="square" lIns="0" tIns="0" rIns="0" bIns="0" rtlCol="0" anchor="t"/>
-          <a:lstStyle/>
-          <a:p>
-            <a:pPr marL="0" indent="0">
-              <a:buNone/>
-            </a:pPr>
-            <a:r>
-              <a:rPr lang="en-US" sz="950" b="1" kern="0" spc="150" dirty="0">
-                <a:solidFill>
-                  <a:srgbClr val="E3202A"/>
-                </a:solidFill>
-                <a:latin typeface="Calibri" pitchFamily="34" charset="0"/>
-                <a:ea typeface="Calibri" pitchFamily="34" charset="-122"/>
-                <a:cs typeface="Calibri" pitchFamily="34" charset="-120"/>
-              </a:rPr>
-              <a:t>HOSPITALITY</a:t>
-            </a:r>
-            <a:endParaRPr lang="en-US" sz="950" dirty="0"/>
-          </a:p>
-        </p:txBody>
-      </p:sp>
-      <p:sp>
-        <p:nvSpPr>
-          <p:cNvPr id="9" name="Text 5"/>
-          <p:cNvSpPr txBox="1"/>
-          <p:nvPr/>
-        </p:nvSpPr>
-        <p:spPr>
-          <a:xfrm>
-            <a:off x="1468680" y="3470000"/>
-            <a:ext cx="2235098" cy="310896"/>
-          </a:xfrm>
-          <a:prstGeom prst="rect">
-            <a:avLst/>
-          </a:prstGeom>
-          <a:noFill/>
-          <a:ln/>
-        </p:spPr>
-        <p:txBody>
-          <a:bodyPr wrap="square" lIns="0" tIns="0" rIns="0" bIns="0" rtlCol="0" anchor="t"/>
-          <a:lstStyle/>
-          <a:p>
-            <a:pPr marL="0" indent="0">
-              <a:buNone/>
-            </a:pPr>
-            <a:r>
-              <a:rPr lang="en-US" sz="1500" b="1" dirty="0">
-                <a:solidFill>
-                  <a:srgbClr val="151A21"/>
-                </a:solidFill>
-                <a:latin typeface="Arial" pitchFamily="34" charset="0"/>
-                <a:ea typeface="Arial" pitchFamily="34" charset="-122"/>
-                <a:cs typeface="Arial" pitchFamily="34" charset="-120"/>
-              </a:rPr>
-              <a:t>Hospitality chain</a:t>
-            </a:r>
-            <a:endParaRPr lang="en-US" sz="1500" dirty="0"/>
-          </a:p>
-        </p:txBody>
-      </p:sp>
-      <p:sp>
-        <p:nvSpPr>
-          <p:cNvPr id="10" name="Text 6"/>
-          <p:cNvSpPr txBox="1"/>
-          <p:nvPr/>
-        </p:nvSpPr>
-        <p:spPr>
-          <a:xfrm>
-            <a:off x="868680" y="3760000"/>
-            <a:ext cx="2875178" cy="520000"/>
-          </a:xfrm>
-          <a:prstGeom prst="rect">
-            <a:avLst/>
-          </a:prstGeom>
-          <a:noFill/>
-          <a:ln/>
-        </p:spPr>
-        <p:txBody>
-          <a:bodyPr wrap="square" lIns="0" tIns="0" rIns="0" bIns="0" rtlCol="0" anchor="ctr"/>
-          <a:lstStyle/>
-          <a:p>
-            <a:pPr marL="0" indent="0">
-              <a:buNone/>
-            </a:pPr>
-            <a:r>
-              <a:rPr lang="en-US" sz="3200" b="1" dirty="0">
-                <a:solidFill>
-                  <a:srgbClr val="E3202A"/>
-                </a:solidFill>
-                <a:latin typeface="Arial" pitchFamily="34" charset="0"/>
-                <a:ea typeface="Arial" pitchFamily="34" charset="-122"/>
-                <a:cs typeface="Arial" pitchFamily="34" charset="-120"/>
-              </a:rPr>
-              <a:t>100K</a:t>
-            </a:r>
-            <a:endParaRPr lang="en-US" sz="4800" dirty="0"/>
-          </a:p>
-        </p:txBody>
-      </p:sp>
-      <p:sp>
-        <p:nvSpPr>
-          <p:cNvPr id="11" name="Text 7"/>
-          <p:cNvSpPr txBox="1"/>
-          <p:nvPr/>
-        </p:nvSpPr>
-        <p:spPr>
-          <a:xfrm>
-            <a:off x="868680" y="4280000"/>
-            <a:ext cx="2875178" cy="292608"/>
-          </a:xfrm>
-          <a:prstGeom prst="rect">
-            <a:avLst/>
-          </a:prstGeom>
-          <a:noFill/>
-          <a:ln/>
-        </p:spPr>
-        <p:txBody>
-          <a:bodyPr wrap="square" lIns="0" tIns="0" rIns="0" bIns="0" rtlCol="0" anchor="t"/>
-          <a:lstStyle/>
-          <a:p>
-            <a:pPr marL="0" indent="0">
-              <a:buNone/>
-            </a:pPr>
-            <a:r>
-              <a:rPr lang="en-US" sz="1300" b="1" dirty="0">
-                <a:solidFill>
-                  <a:srgbClr val="151A21"/>
-                </a:solidFill>
-                <a:latin typeface="Calibri" pitchFamily="34" charset="0"/>
-                <a:ea typeface="Calibri" pitchFamily="34" charset="-122"/>
-                <a:cs typeface="Calibri" pitchFamily="34" charset="-120"/>
-              </a:rPr>
-              <a:t>agents deployed in one day</a:t>
-            </a:r>
-            <a:endParaRPr lang="en-US" sz="1300" dirty="0"/>
-          </a:p>
-        </p:txBody>
-      </p:sp>
-      <p:sp>
-        <p:nvSpPr>
-          <p:cNvPr id="12" name="Text 8"/>
-          <p:cNvSpPr txBox="1"/>
-          <p:nvPr/>
-        </p:nvSpPr>
-        <p:spPr>
-          <a:xfrm>
-            <a:off x="868680" y="4550000"/>
-            <a:ext cx="2875178" cy="340000"/>
-          </a:xfrm>
-          <a:prstGeom prst="rect">
-            <a:avLst/>
-          </a:prstGeom>
-          <a:noFill/>
-          <a:ln/>
-        </p:spPr>
-        <p:txBody>
-          <a:bodyPr wrap="square" lIns="0" tIns="0" rIns="0" bIns="0" rtlCol="0" anchor="t"/>
-          <a:lstStyle/>
-          <a:p>
-            <a:pPr marL="0" indent="0">
-              <a:buNone/>
-            </a:pPr>
-            <a:r>
-              <a:rPr lang="en-US" sz="1150" dirty="0">
-                <a:solidFill>
-                  <a:srgbClr val="5E6978"/>
-                </a:solidFill>
-                <a:latin typeface="Calibri" pitchFamily="34" charset="0"/>
-                <a:ea typeface="Calibri" pitchFamily="34" charset="-122"/>
-                <a:cs typeface="Calibri" pitchFamily="34" charset="-120"/>
-              </a:rPr>
-              <a:t>Rolled out in one day during an incident response.</a:t>
-            </a:r>
-            <a:endParaRPr lang="en-US" sz="1150" dirty="0"/>
-          </a:p>
-        </p:txBody>
-      </p:sp>
-      <p:sp>
-        <p:nvSpPr>
-          <p:cNvPr id="13" name="Shape 9"/>
-          <p:cNvSpPr/>
-          <p:nvPr/>
-        </p:nvSpPr>
-        <p:spPr>
-          <a:xfrm>
-            <a:off x="4338218" y="3080000"/>
-            <a:ext cx="3515258" cy="1900000"/>
-          </a:xfrm>
-          <a:prstGeom prst="roundRect">
-            <a:avLst>
-              <a:gd name="adj" fmla="val 2601"/>
-            </a:avLst>
-          </a:prstGeom>
-          <a:solidFill>
-            <a:srgbClr val="F3F5F8"/>
-          </a:solidFill>
-          <a:ln w="9525">
-            <a:solidFill>
-              <a:srgbClr val="DCE1E7"/>
-            </a:solidFill>
-            <a:prstDash val="solid"/>
-          </a:ln>
-        </p:spPr>
-      </p:sp>
-      <p:sp>
-        <p:nvSpPr>
-          <p:cNvPr id="14" name="Shape 10"/>
-          <p:cNvSpPr/>
-          <p:nvPr/>
-        </p:nvSpPr>
-        <p:spPr>
-          <a:xfrm>
-            <a:off x="4658258" y="3240000"/>
-            <a:ext cx="457200" cy="457200"/>
-          </a:xfrm>
-          <a:prstGeom prst="roundRect">
-            <a:avLst>
-              <a:gd name="adj" fmla="val 16667"/>
-            </a:avLst>
-          </a:prstGeom>
-          <a:solidFill>
-            <a:srgbClr val="EAEEF3"/>
-          </a:solidFill>
-          <a:ln w="12700">
-            <a:solidFill>
-              <a:srgbClr val="EAEEF3"/>
-            </a:solidFill>
-            <a:prstDash val="solid"/>
-          </a:ln>
-        </p:spPr>
-      </p:sp>
-      <p:pic>
-        <p:nvPicPr>
-          <p:cNvPr id="15" name="Image 2" descr="preencoded.png"/>
-          <p:cNvPicPr>
-            <a:picLocks noChangeAspect="1"/>
-          </p:cNvPicPr>
-          <p:nvPr/>
-        </p:nvPicPr>
-        <p:blipFill>
-          <a:blip r:embed="rId5"/>
-          <a:stretch>
-            <a:fillRect/>
-          </a:stretch>
-        </p:blipFill>
-        <p:spPr>
-          <a:xfrm>
-            <a:off x="4733258" y="3315000"/>
-            <a:ext cx="307238" cy="307238"/>
-          </a:xfrm>
-          <a:prstGeom prst="rect">
-            <a:avLst/>
-          </a:prstGeom>
-        </p:spPr>
-      </p:pic>
-      <p:sp>
-        <p:nvSpPr>
-          <p:cNvPr id="16" name="Text 11"/>
-          <p:cNvSpPr txBox="1"/>
-          <p:nvPr/>
-        </p:nvSpPr>
-        <p:spPr>
-          <a:xfrm>
-            <a:off x="5258258" y="3245000"/>
-            <a:ext cx="2235098" cy="237744"/>
-          </a:xfrm>
-          <a:prstGeom prst="rect">
-            <a:avLst/>
-          </a:prstGeom>
-          <a:noFill/>
-          <a:ln/>
-        </p:spPr>
-        <p:txBody>
-          <a:bodyPr wrap="square" lIns="0" tIns="0" rIns="0" bIns="0" rtlCol="0" anchor="t"/>
-          <a:lstStyle/>
-          <a:p>
-            <a:pPr marL="0" indent="0">
-              <a:buNone/>
-            </a:pPr>
-            <a:r>
-              <a:rPr lang="en-US" sz="950" b="1" kern="0" spc="150" dirty="0">
-                <a:solidFill>
-                  <a:srgbClr val="5D6B7E"/>
-                </a:solidFill>
-                <a:latin typeface="Calibri" pitchFamily="34" charset="0"/>
-                <a:ea typeface="Calibri" pitchFamily="34" charset="-122"/>
-                <a:cs typeface="Calibri" pitchFamily="34" charset="-120"/>
-              </a:rPr>
-              <a:t>EDUCATION</a:t>
-            </a:r>
-            <a:endParaRPr lang="en-US" sz="950" dirty="0"/>
-          </a:p>
-        </p:txBody>
-      </p:sp>
-      <p:sp>
-        <p:nvSpPr>
-          <p:cNvPr id="17" name="Text 12"/>
-          <p:cNvSpPr txBox="1"/>
-          <p:nvPr/>
-        </p:nvSpPr>
-        <p:spPr>
-          <a:xfrm>
-            <a:off x="5258258" y="3470000"/>
-            <a:ext cx="2235098" cy="310896"/>
-          </a:xfrm>
-          <a:prstGeom prst="rect">
-            <a:avLst/>
-          </a:prstGeom>
-          <a:noFill/>
-          <a:ln/>
-        </p:spPr>
-        <p:txBody>
-          <a:bodyPr wrap="square" lIns="0" tIns="0" rIns="0" bIns="0" rtlCol="0" anchor="t"/>
-          <a:lstStyle/>
-          <a:p>
-            <a:pPr marL="0" indent="0">
-              <a:buNone/>
-            </a:pPr>
-            <a:r>
-              <a:rPr lang="en-US" sz="1500" b="1" dirty="0">
-                <a:solidFill>
-                  <a:srgbClr val="151A21"/>
-                </a:solidFill>
-                <a:latin typeface="Arial" pitchFamily="34" charset="0"/>
-                <a:ea typeface="Arial" pitchFamily="34" charset="-122"/>
-                <a:cs typeface="Arial" pitchFamily="34" charset="-120"/>
-              </a:rPr>
-              <a:t>Coventry University</a:t>
-            </a:r>
-            <a:endParaRPr lang="en-US" sz="1500" dirty="0"/>
-          </a:p>
-        </p:txBody>
-      </p:sp>
-      <p:sp>
-        <p:nvSpPr>
-          <p:cNvPr id="18" name="Text 13"/>
-          <p:cNvSpPr txBox="1"/>
-          <p:nvPr/>
-        </p:nvSpPr>
-        <p:spPr>
-          <a:xfrm>
-            <a:off x="4658258" y="3760000"/>
-            <a:ext cx="2875178" cy="520000"/>
-          </a:xfrm>
-          <a:prstGeom prst="rect">
-            <a:avLst/>
-          </a:prstGeom>
-          <a:noFill/>
-          <a:ln/>
-        </p:spPr>
-        <p:txBody>
-          <a:bodyPr wrap="square" lIns="0" tIns="0" rIns="0" bIns="0" rtlCol="0" anchor="ctr"/>
-          <a:lstStyle/>
-          <a:p>
-            <a:pPr marL="0" indent="0">
-              <a:buNone/>
-            </a:pPr>
-            <a:r>
-              <a:rPr lang="en-US" sz="3200" b="1" dirty="0">
-                <a:solidFill>
-                  <a:srgbClr val="E3202A"/>
-                </a:solidFill>
-                <a:latin typeface="Arial" pitchFamily="34" charset="0"/>
-                <a:ea typeface="Arial" pitchFamily="34" charset="-122"/>
-                <a:cs typeface="Arial" pitchFamily="34" charset="-120"/>
-              </a:rPr>
-              <a:t>94%</a:t>
-            </a:r>
-            <a:endParaRPr lang="en-US" sz="4800" dirty="0"/>
-          </a:p>
-        </p:txBody>
-      </p:sp>
-      <p:sp>
-        <p:nvSpPr>
-          <p:cNvPr id="19" name="Text 14"/>
-          <p:cNvSpPr txBox="1"/>
-          <p:nvPr/>
-        </p:nvSpPr>
-        <p:spPr>
-          <a:xfrm>
-            <a:off x="4658258" y="4280000"/>
-            <a:ext cx="2875178" cy="292608"/>
-          </a:xfrm>
-          <a:prstGeom prst="rect">
-            <a:avLst/>
-          </a:prstGeom>
-          <a:noFill/>
-          <a:ln/>
-        </p:spPr>
-        <p:txBody>
-          <a:bodyPr wrap="square" lIns="0" tIns="0" rIns="0" bIns="0" rtlCol="0" anchor="t"/>
-          <a:lstStyle/>
-          <a:p>
-            <a:pPr marL="0" indent="0">
-              <a:buNone/>
-            </a:pPr>
-            <a:r>
-              <a:rPr lang="en-US" sz="1300" b="1" dirty="0">
-                <a:solidFill>
-                  <a:srgbClr val="151A21"/>
-                </a:solidFill>
-                <a:latin typeface="Calibri" pitchFamily="34" charset="0"/>
-                <a:ea typeface="Calibri" pitchFamily="34" charset="-122"/>
-                <a:cs typeface="Calibri" pitchFamily="34" charset="-120"/>
-              </a:rPr>
-              <a:t>faster threat resolution</a:t>
-            </a:r>
-            <a:endParaRPr lang="en-US" sz="1300" dirty="0"/>
-          </a:p>
-        </p:txBody>
-      </p:sp>
-      <p:sp>
-        <p:nvSpPr>
-          <p:cNvPr id="20" name="Text 15"/>
-          <p:cNvSpPr txBox="1"/>
-          <p:nvPr/>
-        </p:nvSpPr>
-        <p:spPr>
-          <a:xfrm>
-            <a:off x="4658258" y="4550000"/>
-            <a:ext cx="2875178" cy="340000"/>
-          </a:xfrm>
-          <a:prstGeom prst="rect">
-            <a:avLst/>
-          </a:prstGeom>
-          <a:noFill/>
-          <a:ln/>
-        </p:spPr>
-        <p:txBody>
-          <a:bodyPr wrap="square" lIns="0" tIns="0" rIns="0" bIns="0" rtlCol="0" anchor="t"/>
-          <a:lstStyle/>
-          <a:p>
-            <a:pPr marL="0" indent="0">
-              <a:buNone/>
-            </a:pPr>
-            <a:r>
-              <a:rPr lang="en-US" sz="1150" dirty="0">
-                <a:solidFill>
-                  <a:srgbClr val="5E6978"/>
-                </a:solidFill>
-                <a:latin typeface="Calibri" pitchFamily="34" charset="0"/>
-                <a:ea typeface="Calibri" pitchFamily="34" charset="-122"/>
-                <a:cs typeface="Calibri" pitchFamily="34" charset="-120"/>
-              </a:rPr>
-              <a:t>Incident resolution fell from 2–3 days to under 1 hour.</a:t>
-            </a:r>
-            <a:endParaRPr lang="en-US" sz="1150" dirty="0"/>
-          </a:p>
-        </p:txBody>
-      </p:sp>
-      <p:sp>
-        <p:nvSpPr>
-          <p:cNvPr id="21" name="Shape 16"/>
-          <p:cNvSpPr/>
-          <p:nvPr/>
-        </p:nvSpPr>
-        <p:spPr>
-          <a:xfrm>
-            <a:off x="8127797" y="3080000"/>
-            <a:ext cx="3515258" cy="1900000"/>
-          </a:xfrm>
-          <a:prstGeom prst="roundRect">
-            <a:avLst>
-              <a:gd name="adj" fmla="val 2601"/>
-            </a:avLst>
-          </a:prstGeom>
-          <a:solidFill>
-            <a:srgbClr val="F3F5F8"/>
-          </a:solidFill>
-          <a:ln w="9525">
-            <a:solidFill>
-              <a:srgbClr val="DCE1E7"/>
-            </a:solidFill>
-            <a:prstDash val="solid"/>
-          </a:ln>
-        </p:spPr>
-      </p:sp>
-      <p:sp>
-        <p:nvSpPr>
-          <p:cNvPr id="22" name="Shape 17"/>
-          <p:cNvSpPr/>
-          <p:nvPr/>
-        </p:nvSpPr>
-        <p:spPr>
-          <a:xfrm>
-            <a:off x="8447837" y="3240000"/>
-            <a:ext cx="457200" cy="457200"/>
-          </a:xfrm>
-          <a:prstGeom prst="roundRect">
-            <a:avLst>
-              <a:gd name="adj" fmla="val 16667"/>
-            </a:avLst>
-          </a:prstGeom>
-          <a:solidFill>
-            <a:srgbClr val="EAEEF3"/>
-          </a:solidFill>
-          <a:ln w="12700">
-            <a:solidFill>
-              <a:srgbClr val="EAEEF3"/>
-            </a:solidFill>
-            <a:prstDash val="solid"/>
-          </a:ln>
-        </p:spPr>
-      </p:sp>
-      <p:pic>
-        <p:nvPicPr>
-          <p:cNvPr id="23" name="Image 3" descr="preencoded.png"/>
-          <p:cNvPicPr>
-            <a:picLocks noChangeAspect="1"/>
-          </p:cNvPicPr>
-          <p:nvPr/>
-        </p:nvPicPr>
-        <p:blipFill>
-          <a:blip r:embed="rId6"/>
-          <a:stretch>
-            <a:fillRect/>
-          </a:stretch>
-        </p:blipFill>
-        <p:spPr>
-          <a:xfrm>
-            <a:off x="8522837" y="3315000"/>
-            <a:ext cx="307238" cy="307238"/>
-          </a:xfrm>
-          <a:prstGeom prst="rect">
-            <a:avLst/>
-          </a:prstGeom>
-        </p:spPr>
-      </p:pic>
-      <p:sp>
-        <p:nvSpPr>
-          <p:cNvPr id="24" name="Text 18"/>
-          <p:cNvSpPr txBox="1"/>
-          <p:nvPr/>
-        </p:nvSpPr>
-        <p:spPr>
-          <a:xfrm>
-            <a:off x="9047837" y="3245000"/>
-            <a:ext cx="2235098" cy="237744"/>
-          </a:xfrm>
-          <a:prstGeom prst="rect">
-            <a:avLst/>
-          </a:prstGeom>
-          <a:noFill/>
-          <a:ln/>
-        </p:spPr>
-        <p:txBody>
-          <a:bodyPr wrap="square" lIns="0" tIns="0" rIns="0" bIns="0" rtlCol="0" anchor="t"/>
-          <a:lstStyle/>
-          <a:p>
-            <a:pPr marL="0" indent="0">
-              <a:buNone/>
-            </a:pPr>
-            <a:r>
-              <a:rPr lang="en-US" sz="950" b="1" kern="0" spc="150" dirty="0">
-                <a:solidFill>
-                  <a:srgbClr val="5D6B7E"/>
-                </a:solidFill>
-                <a:latin typeface="Calibri" pitchFamily="34" charset="0"/>
-                <a:ea typeface="Calibri" pitchFamily="34" charset="-122"/>
-                <a:cs typeface="Calibri" pitchFamily="34" charset="-120"/>
-              </a:rPr>
-              <a:t>MULTI-BRAND ENTERPRISE</a:t>
-            </a:r>
-            <a:endParaRPr lang="en-US" sz="950" dirty="0"/>
-          </a:p>
-        </p:txBody>
-      </p:sp>
-      <p:sp>
-        <p:nvSpPr>
-          <p:cNvPr id="25" name="Text 19"/>
-          <p:cNvSpPr txBox="1"/>
-          <p:nvPr/>
-        </p:nvSpPr>
-        <p:spPr>
-          <a:xfrm>
-            <a:off x="9047837" y="3470000"/>
-            <a:ext cx="2235098" cy="310896"/>
-          </a:xfrm>
-          <a:prstGeom prst="rect">
-            <a:avLst/>
-          </a:prstGeom>
-          <a:noFill/>
-          <a:ln/>
-        </p:spPr>
-        <p:txBody>
-          <a:bodyPr wrap="square" lIns="0" tIns="0" rIns="0" bIns="0" rtlCol="0" anchor="t"/>
-          <a:lstStyle/>
-          <a:p>
-            <a:pPr marL="0" indent="0">
-              <a:buNone/>
-            </a:pPr>
-            <a:r>
-              <a:rPr lang="en-US" sz="1500" b="1" dirty="0">
-                <a:solidFill>
-                  <a:srgbClr val="151A21"/>
-                </a:solidFill>
-                <a:latin typeface="Arial" pitchFamily="34" charset="0"/>
-                <a:ea typeface="Arial" pitchFamily="34" charset="-122"/>
-                <a:cs typeface="Arial" pitchFamily="34" charset="-120"/>
-              </a:rPr>
-              <a:t>Anywhere Real Estate</a:t>
-            </a:r>
-            <a:endParaRPr lang="en-US" sz="1500" dirty="0"/>
-          </a:p>
-        </p:txBody>
-      </p:sp>
-      <p:sp>
-        <p:nvSpPr>
-          <p:cNvPr id="26" name="Text 20"/>
-          <p:cNvSpPr txBox="1"/>
-          <p:nvPr/>
-        </p:nvSpPr>
-        <p:spPr>
-          <a:xfrm>
-            <a:off x="8447837" y="3760000"/>
-            <a:ext cx="2875178" cy="520000"/>
-          </a:xfrm>
-          <a:prstGeom prst="rect">
-            <a:avLst/>
-          </a:prstGeom>
-          <a:noFill/>
-          <a:ln/>
-        </p:spPr>
-        <p:txBody>
-          <a:bodyPr wrap="square" lIns="0" tIns="0" rIns="0" bIns="0" rtlCol="0" anchor="ctr"/>
-          <a:lstStyle/>
-          <a:p>
-            <a:pPr marL="0" indent="0">
-              <a:buNone/>
-            </a:pPr>
-            <a:r>
-              <a:rPr lang="en-US" sz="3200" b="1" dirty="0">
-                <a:solidFill>
-                  <a:srgbClr val="E3202A"/>
-                </a:solidFill>
-                <a:latin typeface="Arial" pitchFamily="34" charset="0"/>
-                <a:ea typeface="Arial" pitchFamily="34" charset="-122"/>
-                <a:cs typeface="Arial" pitchFamily="34" charset="-120"/>
-              </a:rPr>
-              <a:t>500×</a:t>
-            </a:r>
-            <a:endParaRPr lang="en-US" sz="4800" dirty="0"/>
-          </a:p>
-        </p:txBody>
-      </p:sp>
-      <p:sp>
-        <p:nvSpPr>
-          <p:cNvPr id="27" name="Text 21"/>
-          <p:cNvSpPr txBox="1"/>
-          <p:nvPr/>
-        </p:nvSpPr>
-        <p:spPr>
-          <a:xfrm>
-            <a:off x="8447837" y="4280000"/>
-            <a:ext cx="2875178" cy="292608"/>
-          </a:xfrm>
-          <a:prstGeom prst="rect">
-            <a:avLst/>
-          </a:prstGeom>
-          <a:noFill/>
-          <a:ln/>
-        </p:spPr>
-        <p:txBody>
-          <a:bodyPr wrap="square" lIns="0" tIns="0" rIns="0" bIns="0" rtlCol="0" anchor="t"/>
-          <a:lstStyle/>
-          <a:p>
-            <a:pPr marL="0" indent="0">
-              <a:buNone/>
-            </a:pPr>
-            <a:r>
-              <a:rPr lang="en-US" sz="1300" b="1" dirty="0">
-                <a:solidFill>
-                  <a:srgbClr val="151A21"/>
-                </a:solidFill>
-                <a:latin typeface="Calibri" pitchFamily="34" charset="0"/>
-                <a:ea typeface="Calibri" pitchFamily="34" charset="-122"/>
-                <a:cs typeface="Calibri" pitchFamily="34" charset="-120"/>
-              </a:rPr>
-              <a:t>fewer alerts</a:t>
-            </a:r>
-            <a:endParaRPr lang="en-US" sz="1300" dirty="0"/>
-          </a:p>
-        </p:txBody>
-      </p:sp>
-      <p:sp>
-        <p:nvSpPr>
-          <p:cNvPr id="28" name="Text 22"/>
-          <p:cNvSpPr txBox="1"/>
-          <p:nvPr/>
-        </p:nvSpPr>
-        <p:spPr>
-          <a:xfrm>
-            <a:off x="8447837" y="4550000"/>
-            <a:ext cx="2875178" cy="340000"/>
-          </a:xfrm>
-          <a:prstGeom prst="rect">
-            <a:avLst/>
-          </a:prstGeom>
-          <a:noFill/>
-          <a:ln/>
-        </p:spPr>
-        <p:txBody>
-          <a:bodyPr wrap="square" lIns="0" tIns="0" rIns="0" bIns="0" rtlCol="0" anchor="t"/>
-          <a:lstStyle/>
-          <a:p>
-            <a:pPr marL="0" indent="0">
-              <a:buNone/>
-            </a:pPr>
-            <a:r>
-              <a:rPr lang="en-US" sz="1150" dirty="0">
-                <a:solidFill>
-                  <a:srgbClr val="5E6978"/>
-                </a:solidFill>
-                <a:latin typeface="Calibri" pitchFamily="34" charset="0"/>
-                <a:ea typeface="Calibri" pitchFamily="34" charset="-122"/>
-                <a:cs typeface="Calibri" pitchFamily="34" charset="-120"/>
-              </a:rPr>
-              <a:t>98% of remaining alerts are real threats.</a:t>
-            </a:r>
-            <a:endParaRPr lang="en-US" sz="1150" dirty="0"/>
-          </a:p>
-        </p:txBody>
-      </p:sp>
-      <p:sp>
-        <p:nvSpPr>
-          <p:cNvPr id="31" name="Text 24"/>
-          <p:cNvSpPr txBox="1"/>
-          <p:nvPr/>
-        </p:nvSpPr>
-        <p:spPr>
-          <a:xfrm>
-            <a:off x="548640" y="6446520"/>
-            <a:ext cx="7315200" cy="219456"/>
-          </a:xfrm>
-          <a:prstGeom prst="rect">
-            <a:avLst/>
-          </a:prstGeom>
-          <a:noFill/>
-          <a:ln/>
-        </p:spPr>
-        <p:txBody>
-          <a:bodyPr wrap="square" lIns="0" tIns="0" rIns="0" bIns="0" rtlCol="0" anchor="ctr"/>
-          <a:lstStyle/>
-          <a:p>
-            <a:pPr marL="0" indent="0">
-              <a:buNone/>
-            </a:pPr>
-            <a:r>
-              <a:rPr lang="en-US" sz="900" dirty="0">
-                <a:solidFill>
-                  <a:srgbClr val="5E6978"/>
-                </a:solidFill>
-                <a:latin typeface="Calibri" pitchFamily="34" charset="0"/>
-                <a:ea typeface="Calibri" pitchFamily="34" charset="-122"/>
-                <a:cs typeface="Calibri" pitchFamily="34" charset="-120"/>
-              </a:rPr>
-              <a:t>06   |   CrowdStrike Falcon Proposal  ·  The Westin Resort Guam</a:t>
-            </a:r>
-            <a:endParaRPr lang="en-US" sz="900" dirty="0"/>
-          </a:p>
-        </p:txBody>
-      </p:sp>
-      <p:pic>
-        <p:nvPicPr>
-          <p:cNvPr id="32" name="Image 5" descr="/private/tmp/claude-501/-Users-jihanvin-Desktop-NIVNAH-AI/16a96446-d9b3-40e2-af9e-a3011ae3db84/scratchpad/assets/secukorea_dark.png"/>
-          <p:cNvPicPr>
-            <a:picLocks noChangeAspect="1"/>
-          </p:cNvPicPr>
-          <p:nvPr/>
-        </p:nvPicPr>
-        <p:blipFill>
-          <a:blip r:embed="rId8"/>
-          <a:stretch>
-            <a:fillRect/>
-          </a:stretch>
-        </p:blipFill>
-        <p:spPr>
-          <a:xfrm>
-            <a:off x="10661904" y="6400800"/>
-            <a:ext cx="978408" cy="233172"/>
-          </a:xfrm>
-          <a:prstGeom prst="rect">
-            <a:avLst/>
-          </a:prstGeom>
-        </p:spPr>
-      </p:pic>
-      <p:sp>
-        <p:nvSpPr>
-          <p:cNvPr id="33" name="TextBox 32"/>
-          <p:cNvSpPr txBox="1"/>
-          <p:nvPr/>
-        </p:nvSpPr>
-        <p:spPr>
-          <a:xfrm>
-            <a:off x="548640" y="1330000"/>
-            <a:ext cx="11094415" cy="240000"/>
-          </a:xfrm>
-          <a:prstGeom prst="rect">
-            <a:avLst/>
-          </a:prstGeom>
-          <a:noFill/>
-        </p:spPr>
-        <p:txBody>
-          <a:bodyPr wrap="square" lIns="0" rIns="0" tIns="0" bIns="0" anchor="t">
-            <a:spAutoFit/>
-          </a:bodyPr>
-          <a:lstStyle/>
-          <a:p>
-            <a:pPr algn="l"/>
-            <a:r>
-              <a:rPr sz="1000" b="1">
-                <a:solidFill>
-                  <a:srgbClr val="E3202A"/>
-                </a:solidFill>
-                <a:latin typeface="Calibri"/>
-              </a:rPr>
-              <a:t>REAL ATTACK  ·  </a:t>
-            </a:r>
-            <a:r>
-              <a:rPr sz="1200" b="1">
-                <a:solidFill>
-                  <a:srgbClr val="1D2025"/>
-                </a:solidFill>
-                <a:latin typeface="Calibri"/>
-              </a:rPr>
-              <a:t>A ransomware gang targeted a North American company  —  </a:t>
-            </a:r>
-            <a:r>
-              <a:rPr sz="1200" b="1">
-                <a:solidFill>
-                  <a:srgbClr val="E3202A"/>
-                </a:solidFill>
-                <a:latin typeface="Calibri"/>
-              </a:rPr>
-              <a:t>Result: stopped before a single file was encrypted</a:t>
-            </a:r>
-          </a:p>
-        </p:txBody>
-      </p:sp>
-      <p:sp>
-        <p:nvSpPr>
-          <p:cNvPr id="34" name="Rounded Rectangle 33"/>
-          <p:cNvSpPr/>
-          <p:nvPr/>
-        </p:nvSpPr>
-        <p:spPr>
-          <a:xfrm>
-            <a:off x="548640" y="1640000"/>
-            <a:ext cx="2398603" cy="1100000"/>
-          </a:xfrm>
-          <a:prstGeom prst="roundRect">
-            <a:avLst>
-              <a:gd name="adj" fmla="val 8000"/>
-            </a:avLst>
-          </a:prstGeom>
-          <a:solidFill>
-            <a:srgbClr val="F3F5F8"/>
-          </a:solidFill>
-          <a:ln w="9525">
-            <a:solidFill>
-              <a:srgbClr val="DCE1E7"/>
-            </a:solidFill>
-          </a:ln>
-          <a:effectLst/>
-        </p:spPr>
-        <p:style>
-          <a:lnRef idx="1">
-            <a:schemeClr val="accent1"/>
-          </a:lnRef>
-          <a:fillRef idx="3">
-            <a:schemeClr val="accent1"/>
-          </a:fillRef>
-          <a:effectRef idx="2">
-            <a:schemeClr val="accent1"/>
-          </a:effectRef>
-          <a:fontRef idx="minor">
-            <a:schemeClr val="lt1"/>
-          </a:fontRef>
-        </p:style>
-        <p:txBody>
-          <a:bodyPr rtlCol="0" anchor="ctr"/>
-          <a:lstStyle/>
-          <a:p>
-            <a:pPr algn="ctr"/>
-          </a:p>
-        </p:txBody>
-      </p:sp>
-      <p:sp>
-        <p:nvSpPr>
-          <p:cNvPr id="35" name="Oval 34"/>
-          <p:cNvSpPr/>
-          <p:nvPr/>
-        </p:nvSpPr>
-        <p:spPr>
-          <a:xfrm>
-            <a:off x="698640" y="1790000"/>
-            <a:ext cx="320000" cy="320000"/>
-          </a:xfrm>
-          <a:prstGeom prst="ellipse">
-            <a:avLst/>
-          </a:prstGeom>
-          <a:solidFill>
-            <a:srgbClr val="5E6978"/>
-          </a:solidFill>
-          <a:ln>
-            <a:noFill/>
-          </a:ln>
-          <a:effectLst/>
-        </p:spPr>
-        <p:style>
-          <a:lnRef idx="1">
-            <a:schemeClr val="accent1"/>
-          </a:lnRef>
-          <a:fillRef idx="3">
-            <a:schemeClr val="accent1"/>
-          </a:fillRef>
-          <a:effectRef idx="2">
-            <a:schemeClr val="accent1"/>
-          </a:effectRef>
-          <a:fontRef idx="minor">
-            <a:schemeClr val="lt1"/>
-          </a:fontRef>
-        </p:style>
-        <p:txBody>
-          <a:bodyPr rtlCol="0" anchor="ctr" lIns="0" rIns="0" tIns="0" bIns="0"/>
-          <a:lstStyle/>
-          <a:p>
-            <a:pPr algn="ctr"/>
-            <a:r>
-              <a:rPr sz="1200" b="1">
-                <a:solidFill>
-                  <a:srgbClr val="FFFFFF"/>
-                </a:solidFill>
-                <a:latin typeface="Arial"/>
-              </a:rPr>
-              <a:t>1</a:t>
-            </a:r>
-          </a:p>
-        </p:txBody>
-      </p:sp>
-      <p:sp>
-        <p:nvSpPr>
-          <p:cNvPr id="36" name="TextBox 35"/>
-          <p:cNvSpPr txBox="1"/>
-          <p:nvPr/>
-        </p:nvSpPr>
-        <p:spPr>
-          <a:xfrm>
-            <a:off x="1108640" y="1790000"/>
-            <a:ext cx="1758603" cy="320000"/>
-          </a:xfrm>
-          <a:prstGeom prst="rect">
-            <a:avLst/>
-          </a:prstGeom>
-          <a:noFill/>
-        </p:spPr>
-        <p:txBody>
-          <a:bodyPr wrap="square" lIns="0" rIns="0" tIns="0" bIns="0" anchor="ctr">
-            <a:spAutoFit/>
-          </a:bodyPr>
-          <a:lstStyle/>
-          <a:p>
-            <a:pPr algn="l"/>
-            <a:r>
-              <a:rPr sz="1250" b="1">
-                <a:solidFill>
-                  <a:srgbClr val="1D2025"/>
-                </a:solidFill>
-                <a:latin typeface="Calibri"/>
-              </a:rPr>
-              <a:t>Break-in attempt</a:t>
-            </a:r>
-          </a:p>
-        </p:txBody>
-      </p:sp>
-      <p:sp>
-        <p:nvSpPr>
-          <p:cNvPr id="37" name="TextBox 36"/>
-          <p:cNvSpPr txBox="1"/>
-          <p:nvPr/>
-        </p:nvSpPr>
-        <p:spPr>
-          <a:xfrm>
-            <a:off x="698640" y="2200000"/>
-            <a:ext cx="2098603" cy="480000"/>
-          </a:xfrm>
-          <a:prstGeom prst="rect">
-            <a:avLst/>
-          </a:prstGeom>
-          <a:noFill/>
-        </p:spPr>
-        <p:txBody>
-          <a:bodyPr wrap="square" lIns="0" rIns="0" tIns="0" bIns="0" anchor="t">
-            <a:spAutoFit/>
-          </a:bodyPr>
-          <a:lstStyle/>
-          <a:p>
-            <a:pPr algn="l"/>
-            <a:r>
-              <a:rPr sz="1050" b="0">
-                <a:solidFill>
-                  <a:srgbClr val="5E6978"/>
-                </a:solidFill>
-                <a:latin typeface="Calibri"/>
-              </a:rPr>
-              <a:t>Hackers used stolen passwords to get into the network</a:t>
-            </a:r>
-          </a:p>
-        </p:txBody>
-      </p:sp>
-      <p:sp>
-        <p:nvSpPr>
-          <p:cNvPr id="38" name="Right Arrow 37"/>
-          <p:cNvSpPr/>
-          <p:nvPr/>
-        </p:nvSpPr>
-        <p:spPr>
-          <a:xfrm>
-            <a:off x="3097243" y="2090000"/>
-            <a:ext cx="200000" cy="200000"/>
-          </a:xfrm>
-          <a:prstGeom prst="rightArrow">
-            <a:avLst/>
-          </a:prstGeom>
-          <a:solidFill>
-            <a:srgbClr val="E3202A"/>
-          </a:solidFill>
-          <a:ln>
-            <a:noFill/>
-          </a:ln>
-          <a:effectLst/>
-        </p:spPr>
-        <p:style>
-          <a:lnRef idx="1">
-            <a:schemeClr val="accent1"/>
-          </a:lnRef>
-          <a:fillRef idx="3">
-            <a:schemeClr val="accent1"/>
-          </a:fillRef>
-          <a:effectRef idx="2">
-            <a:schemeClr val="accent1"/>
-          </a:effectRef>
-          <a:fontRef idx="minor">
-            <a:schemeClr val="lt1"/>
-          </a:fontRef>
-        </p:style>
-        <p:txBody>
-          <a:bodyPr rtlCol="0" anchor="ctr"/>
-          <a:lstStyle/>
-          <a:p>
-            <a:pPr algn="ctr"/>
-          </a:p>
-        </p:txBody>
-      </p:sp>
-      <p:sp>
-        <p:nvSpPr>
-          <p:cNvPr id="39" name="Rounded Rectangle 38"/>
-          <p:cNvSpPr/>
-          <p:nvPr/>
-        </p:nvSpPr>
-        <p:spPr>
-          <a:xfrm>
-            <a:off x="3447243" y="1640000"/>
-            <a:ext cx="2398603" cy="1100000"/>
-          </a:xfrm>
-          <a:prstGeom prst="roundRect">
-            <a:avLst>
-              <a:gd name="adj" fmla="val 8000"/>
-            </a:avLst>
-          </a:prstGeom>
-          <a:solidFill>
-            <a:srgbClr val="FDECEC"/>
-          </a:solidFill>
-          <a:ln w="9525">
-            <a:solidFill>
-              <a:srgbClr val="F6C9CB"/>
-            </a:solidFill>
-          </a:ln>
-          <a:effectLst/>
-        </p:spPr>
-        <p:style>
-          <a:lnRef idx="1">
-            <a:schemeClr val="accent1"/>
-          </a:lnRef>
-          <a:fillRef idx="3">
-            <a:schemeClr val="accent1"/>
-          </a:fillRef>
-          <a:effectRef idx="2">
-            <a:schemeClr val="accent1"/>
-          </a:effectRef>
-          <a:fontRef idx="minor">
-            <a:schemeClr val="lt1"/>
-          </a:fontRef>
-        </p:style>
-        <p:txBody>
-          <a:bodyPr rtlCol="0" anchor="ctr"/>
-          <a:lstStyle/>
-          <a:p>
-            <a:pPr algn="ctr"/>
-          </a:p>
-        </p:txBody>
-      </p:sp>
-      <p:sp>
-        <p:nvSpPr>
-          <p:cNvPr id="40" name="Oval 39"/>
-          <p:cNvSpPr/>
-          <p:nvPr/>
-        </p:nvSpPr>
-        <p:spPr>
-          <a:xfrm>
-            <a:off x="3597243" y="1790000"/>
-            <a:ext cx="320000" cy="320000"/>
-          </a:xfrm>
-          <a:prstGeom prst="ellipse">
-            <a:avLst/>
-          </a:prstGeom>
-          <a:solidFill>
-            <a:srgbClr val="E3202A"/>
-          </a:solidFill>
-          <a:ln>
-            <a:noFill/>
-          </a:ln>
-          <a:effectLst/>
-        </p:spPr>
-        <p:style>
-          <a:lnRef idx="1">
-            <a:schemeClr val="accent1"/>
-          </a:lnRef>
-          <a:fillRef idx="3">
-            <a:schemeClr val="accent1"/>
-          </a:fillRef>
-          <a:effectRef idx="2">
-            <a:schemeClr val="accent1"/>
-          </a:effectRef>
-          <a:fontRef idx="minor">
-            <a:schemeClr val="lt1"/>
-          </a:fontRef>
-        </p:style>
-        <p:txBody>
-          <a:bodyPr rtlCol="0" anchor="ctr" lIns="0" rIns="0" tIns="0" bIns="0"/>
-          <a:lstStyle/>
-          <a:p>
-            <a:pPr algn="ctr"/>
-            <a:r>
-              <a:rPr sz="1200" b="1">
-                <a:solidFill>
-                  <a:srgbClr val="FFFFFF"/>
-                </a:solidFill>
-                <a:latin typeface="Arial"/>
-              </a:rPr>
-              <a:t>2</a:t>
-            </a:r>
-          </a:p>
-        </p:txBody>
-      </p:sp>
-      <p:sp>
-        <p:nvSpPr>
-          <p:cNvPr id="41" name="TextBox 40"/>
-          <p:cNvSpPr txBox="1"/>
-          <p:nvPr/>
-        </p:nvSpPr>
-        <p:spPr>
-          <a:xfrm>
-            <a:off x="4007243" y="1790000"/>
-            <a:ext cx="1758603" cy="320000"/>
-          </a:xfrm>
-          <a:prstGeom prst="rect">
-            <a:avLst/>
-          </a:prstGeom>
-          <a:noFill/>
-        </p:spPr>
-        <p:txBody>
-          <a:bodyPr wrap="square" lIns="0" rIns="0" tIns="0" bIns="0" anchor="ctr">
-            <a:spAutoFit/>
-          </a:bodyPr>
-          <a:lstStyle/>
-          <a:p>
-            <a:pPr algn="l"/>
-            <a:r>
-              <a:rPr sz="1250" b="1">
-                <a:solidFill>
-                  <a:srgbClr val="1D2025"/>
-                </a:solidFill>
-                <a:latin typeface="Calibri"/>
-              </a:rPr>
-              <a:t>Spotted at once</a:t>
-            </a:r>
-          </a:p>
-        </p:txBody>
-      </p:sp>
-      <p:sp>
-        <p:nvSpPr>
-          <p:cNvPr id="42" name="TextBox 41"/>
-          <p:cNvSpPr txBox="1"/>
-          <p:nvPr/>
-        </p:nvSpPr>
-        <p:spPr>
-          <a:xfrm>
-            <a:off x="3597243" y="2200000"/>
-            <a:ext cx="2098603" cy="480000"/>
-          </a:xfrm>
-          <a:prstGeom prst="rect">
-            <a:avLst/>
-          </a:prstGeom>
-          <a:noFill/>
-        </p:spPr>
-        <p:txBody>
-          <a:bodyPr wrap="square" lIns="0" rIns="0" tIns="0" bIns="0" anchor="t">
-            <a:spAutoFit/>
-          </a:bodyPr>
-          <a:lstStyle/>
-          <a:p>
-            <a:pPr algn="l"/>
-            <a:r>
-              <a:rPr sz="1050" b="0">
-                <a:solidFill>
-                  <a:srgbClr val="5E6978"/>
-                </a:solidFill>
-                <a:latin typeface="Calibri"/>
-              </a:rPr>
-              <a:t>Falcon flagged the intruder as they moved to other PCs</a:t>
-            </a:r>
-          </a:p>
-        </p:txBody>
-      </p:sp>
-      <p:sp>
-        <p:nvSpPr>
-          <p:cNvPr id="43" name="Right Arrow 42"/>
-          <p:cNvSpPr/>
-          <p:nvPr/>
-        </p:nvSpPr>
-        <p:spPr>
-          <a:xfrm>
-            <a:off x="5995846" y="2090000"/>
-            <a:ext cx="200000" cy="200000"/>
-          </a:xfrm>
-          <a:prstGeom prst="rightArrow">
-            <a:avLst/>
-          </a:prstGeom>
-          <a:solidFill>
-            <a:srgbClr val="E3202A"/>
-          </a:solidFill>
-          <a:ln>
-            <a:noFill/>
-          </a:ln>
-          <a:effectLst/>
-        </p:spPr>
-        <p:style>
-          <a:lnRef idx="1">
-            <a:schemeClr val="accent1"/>
-          </a:lnRef>
-          <a:fillRef idx="3">
-            <a:schemeClr val="accent1"/>
-          </a:fillRef>
-          <a:effectRef idx="2">
-            <a:schemeClr val="accent1"/>
-          </a:effectRef>
-          <a:fontRef idx="minor">
-            <a:schemeClr val="lt1"/>
-          </a:fontRef>
-        </p:style>
-        <p:txBody>
-          <a:bodyPr rtlCol="0" anchor="ctr"/>
-          <a:lstStyle/>
-          <a:p>
-            <a:pPr algn="ctr"/>
-          </a:p>
-        </p:txBody>
-      </p:sp>
-      <p:sp>
-        <p:nvSpPr>
-          <p:cNvPr id="44" name="Rounded Rectangle 43"/>
-          <p:cNvSpPr/>
-          <p:nvPr/>
-        </p:nvSpPr>
-        <p:spPr>
-          <a:xfrm>
-            <a:off x="6345846" y="1640000"/>
-            <a:ext cx="2398603" cy="1100000"/>
-          </a:xfrm>
-          <a:prstGeom prst="roundRect">
-            <a:avLst>
-              <a:gd name="adj" fmla="val 8000"/>
-            </a:avLst>
-          </a:prstGeom>
-          <a:solidFill>
-            <a:srgbClr val="FDECEC"/>
-          </a:solidFill>
-          <a:ln w="9525">
-            <a:solidFill>
-              <a:srgbClr val="F6C9CB"/>
-            </a:solidFill>
-          </a:ln>
-          <a:effectLst/>
-        </p:spPr>
-        <p:style>
-          <a:lnRef idx="1">
-            <a:schemeClr val="accent1"/>
-          </a:lnRef>
-          <a:fillRef idx="3">
-            <a:schemeClr val="accent1"/>
-          </a:fillRef>
-          <a:effectRef idx="2">
-            <a:schemeClr val="accent1"/>
-          </a:effectRef>
-          <a:fontRef idx="minor">
-            <a:schemeClr val="lt1"/>
-          </a:fontRef>
-        </p:style>
-        <p:txBody>
-          <a:bodyPr rtlCol="0" anchor="ctr"/>
-          <a:lstStyle/>
-          <a:p>
-            <a:pPr algn="ctr"/>
-          </a:p>
-        </p:txBody>
-      </p:sp>
-      <p:sp>
-        <p:nvSpPr>
-          <p:cNvPr id="45" name="Oval 44"/>
-          <p:cNvSpPr/>
-          <p:nvPr/>
-        </p:nvSpPr>
-        <p:spPr>
-          <a:xfrm>
-            <a:off x="6495846" y="1790000"/>
-            <a:ext cx="320000" cy="320000"/>
-          </a:xfrm>
-          <a:prstGeom prst="ellipse">
-            <a:avLst/>
-          </a:prstGeom>
-          <a:solidFill>
-            <a:srgbClr val="E3202A"/>
-          </a:solidFill>
-          <a:ln>
-            <a:noFill/>
-          </a:ln>
-          <a:effectLst/>
-        </p:spPr>
-        <p:style>
-          <a:lnRef idx="1">
-            <a:schemeClr val="accent1"/>
-          </a:lnRef>
-          <a:fillRef idx="3">
-            <a:schemeClr val="accent1"/>
-          </a:fillRef>
-          <a:effectRef idx="2">
-            <a:schemeClr val="accent1"/>
-          </a:effectRef>
-          <a:fontRef idx="minor">
-            <a:schemeClr val="lt1"/>
-          </a:fontRef>
-        </p:style>
-        <p:txBody>
-          <a:bodyPr rtlCol="0" anchor="ctr" lIns="0" rIns="0" tIns="0" bIns="0"/>
-          <a:lstStyle/>
-          <a:p>
-            <a:pPr algn="ctr"/>
-            <a:r>
-              <a:rPr sz="1200" b="1">
-                <a:solidFill>
-                  <a:srgbClr val="FFFFFF"/>
-                </a:solidFill>
-                <a:latin typeface="Arial"/>
-              </a:rPr>
-              <a:t>3</a:t>
-            </a:r>
-          </a:p>
-        </p:txBody>
-      </p:sp>
-      <p:sp>
-        <p:nvSpPr>
-          <p:cNvPr id="46" name="TextBox 45"/>
-          <p:cNvSpPr txBox="1"/>
-          <p:nvPr/>
-        </p:nvSpPr>
-        <p:spPr>
-          <a:xfrm>
-            <a:off x="6905846" y="1790000"/>
-            <a:ext cx="1758603" cy="320000"/>
-          </a:xfrm>
-          <a:prstGeom prst="rect">
-            <a:avLst/>
-          </a:prstGeom>
-          <a:noFill/>
-        </p:spPr>
-        <p:txBody>
-          <a:bodyPr wrap="square" lIns="0" rIns="0" tIns="0" bIns="0" anchor="ctr">
-            <a:spAutoFit/>
-          </a:bodyPr>
-          <a:lstStyle/>
-          <a:p>
-            <a:pPr algn="l"/>
-            <a:r>
-              <a:rPr sz="1250" b="1">
-                <a:solidFill>
-                  <a:srgbClr val="1D2025"/>
-                </a:solidFill>
-                <a:latin typeface="Calibri"/>
-              </a:rPr>
-              <a:t>Tools blocked</a:t>
-            </a:r>
-          </a:p>
-        </p:txBody>
-      </p:sp>
-      <p:sp>
-        <p:nvSpPr>
-          <p:cNvPr id="47" name="TextBox 46"/>
-          <p:cNvSpPr txBox="1"/>
-          <p:nvPr/>
-        </p:nvSpPr>
-        <p:spPr>
-          <a:xfrm>
-            <a:off x="6495846" y="2200000"/>
-            <a:ext cx="2098603" cy="480000"/>
-          </a:xfrm>
-          <a:prstGeom prst="rect">
-            <a:avLst/>
-          </a:prstGeom>
-          <a:noFill/>
-        </p:spPr>
-        <p:txBody>
-          <a:bodyPr wrap="square" lIns="0" rIns="0" tIns="0" bIns="0" anchor="t">
-            <a:spAutoFit/>
-          </a:bodyPr>
-          <a:lstStyle/>
-          <a:p>
-            <a:pPr algn="l"/>
-            <a:r>
-              <a:rPr sz="1050" b="0">
-                <a:solidFill>
-                  <a:srgbClr val="5E6978"/>
-                </a:solidFill>
-                <a:latin typeface="Calibri"/>
-              </a:rPr>
-              <a:t>Password theft and hacking tools were stopped</a:t>
-            </a:r>
-          </a:p>
-        </p:txBody>
-      </p:sp>
-      <p:sp>
-        <p:nvSpPr>
-          <p:cNvPr id="48" name="Right Arrow 47"/>
-          <p:cNvSpPr/>
-          <p:nvPr/>
-        </p:nvSpPr>
-        <p:spPr>
-          <a:xfrm>
-            <a:off x="8894449" y="2090000"/>
-            <a:ext cx="200000" cy="200000"/>
-          </a:xfrm>
-          <a:prstGeom prst="rightArrow">
-            <a:avLst/>
-          </a:prstGeom>
-          <a:solidFill>
-            <a:srgbClr val="E3202A"/>
-          </a:solidFill>
-          <a:ln>
-            <a:noFill/>
-          </a:ln>
-          <a:effectLst/>
-        </p:spPr>
-        <p:style>
-          <a:lnRef idx="1">
-            <a:schemeClr val="accent1"/>
-          </a:lnRef>
-          <a:fillRef idx="3">
-            <a:schemeClr val="accent1"/>
-          </a:fillRef>
-          <a:effectRef idx="2">
-            <a:schemeClr val="accent1"/>
-          </a:effectRef>
-          <a:fontRef idx="minor">
-            <a:schemeClr val="lt1"/>
-          </a:fontRef>
-        </p:style>
-        <p:txBody>
-          <a:bodyPr rtlCol="0" anchor="ctr"/>
-          <a:lstStyle/>
-          <a:p>
-            <a:pPr algn="ctr"/>
-          </a:p>
-        </p:txBody>
-      </p:sp>
-      <p:sp>
-        <p:nvSpPr>
-          <p:cNvPr id="49" name="Rounded Rectangle 48"/>
-          <p:cNvSpPr/>
-          <p:nvPr/>
-        </p:nvSpPr>
-        <p:spPr>
-          <a:xfrm>
-            <a:off x="9244449" y="1640000"/>
-            <a:ext cx="2398603" cy="1100000"/>
-          </a:xfrm>
-          <a:prstGeom prst="roundRect">
-            <a:avLst>
-              <a:gd name="adj" fmla="val 8000"/>
-            </a:avLst>
-          </a:prstGeom>
-          <a:solidFill>
-            <a:srgbClr val="FDECEC"/>
-          </a:solidFill>
-          <a:ln w="9525">
-            <a:solidFill>
-              <a:srgbClr val="F6C9CB"/>
-            </a:solidFill>
-          </a:ln>
-          <a:effectLst/>
-        </p:spPr>
-        <p:style>
-          <a:lnRef idx="1">
-            <a:schemeClr val="accent1"/>
-          </a:lnRef>
-          <a:fillRef idx="3">
-            <a:schemeClr val="accent1"/>
-          </a:fillRef>
-          <a:effectRef idx="2">
-            <a:schemeClr val="accent1"/>
-          </a:effectRef>
-          <a:fontRef idx="minor">
-            <a:schemeClr val="lt1"/>
-          </a:fontRef>
-        </p:style>
-        <p:txBody>
-          <a:bodyPr rtlCol="0" anchor="ctr"/>
-          <a:lstStyle/>
-          <a:p>
-            <a:pPr algn="ctr"/>
-          </a:p>
-        </p:txBody>
-      </p:sp>
-      <p:sp>
-        <p:nvSpPr>
-          <p:cNvPr id="50" name="Oval 49"/>
-          <p:cNvSpPr/>
-          <p:nvPr/>
-        </p:nvSpPr>
-        <p:spPr>
-          <a:xfrm>
-            <a:off x="9394449" y="1790000"/>
-            <a:ext cx="320000" cy="320000"/>
-          </a:xfrm>
-          <a:prstGeom prst="ellipse">
-            <a:avLst/>
-          </a:prstGeom>
-          <a:solidFill>
-            <a:srgbClr val="E3202A"/>
-          </a:solidFill>
-          <a:ln>
-            <a:noFill/>
-          </a:ln>
-          <a:effectLst/>
-        </p:spPr>
-        <p:style>
-          <a:lnRef idx="1">
-            <a:schemeClr val="accent1"/>
-          </a:lnRef>
-          <a:fillRef idx="3">
-            <a:schemeClr val="accent1"/>
-          </a:fillRef>
-          <a:effectRef idx="2">
-            <a:schemeClr val="accent1"/>
-          </a:effectRef>
-          <a:fontRef idx="minor">
-            <a:schemeClr val="lt1"/>
-          </a:fontRef>
-        </p:style>
-        <p:txBody>
-          <a:bodyPr rtlCol="0" anchor="ctr" lIns="0" rIns="0" tIns="0" bIns="0"/>
-          <a:lstStyle/>
-          <a:p>
-            <a:pPr algn="ctr"/>
-            <a:r>
-              <a:rPr sz="1200" b="1">
-                <a:solidFill>
-                  <a:srgbClr val="FFFFFF"/>
-                </a:solidFill>
-                <a:latin typeface="Arial"/>
-              </a:rPr>
-              <a:t>4</a:t>
-            </a:r>
-          </a:p>
-        </p:txBody>
-      </p:sp>
-      <p:sp>
-        <p:nvSpPr>
-          <p:cNvPr id="51" name="TextBox 50"/>
-          <p:cNvSpPr txBox="1"/>
-          <p:nvPr/>
-        </p:nvSpPr>
-        <p:spPr>
-          <a:xfrm>
-            <a:off x="9804449" y="1790000"/>
-            <a:ext cx="1758603" cy="320000"/>
-          </a:xfrm>
-          <a:prstGeom prst="rect">
-            <a:avLst/>
-          </a:prstGeom>
-          <a:noFill/>
-        </p:spPr>
-        <p:txBody>
-          <a:bodyPr wrap="square" lIns="0" rIns="0" tIns="0" bIns="0" anchor="ctr">
-            <a:spAutoFit/>
-          </a:bodyPr>
-          <a:lstStyle/>
-          <a:p>
-            <a:pPr algn="l"/>
-            <a:r>
-              <a:rPr sz="1250" b="1">
-                <a:solidFill>
-                  <a:srgbClr val="1D2025"/>
-                </a:solidFill>
-                <a:latin typeface="Calibri"/>
-              </a:rPr>
-              <a:t>Ransomware stopped</a:t>
-            </a:r>
-          </a:p>
-        </p:txBody>
-      </p:sp>
-      <p:sp>
-        <p:nvSpPr>
-          <p:cNvPr id="52" name="TextBox 51"/>
-          <p:cNvSpPr txBox="1"/>
-          <p:nvPr/>
-        </p:nvSpPr>
-        <p:spPr>
-          <a:xfrm>
-            <a:off x="9394449" y="2200000"/>
-            <a:ext cx="2098603" cy="480000"/>
-          </a:xfrm>
-          <a:prstGeom prst="rect">
-            <a:avLst/>
-          </a:prstGeom>
-          <a:noFill/>
-        </p:spPr>
-        <p:txBody>
-          <a:bodyPr wrap="square" lIns="0" rIns="0" tIns="0" bIns="0" anchor="t">
-            <a:spAutoFit/>
-          </a:bodyPr>
-          <a:lstStyle/>
-          <a:p>
-            <a:pPr algn="l"/>
-            <a:r>
-              <a:rPr sz="1050" b="0">
-                <a:solidFill>
-                  <a:srgbClr val="5E6978"/>
-                </a:solidFill>
-                <a:latin typeface="Calibri"/>
-              </a:rPr>
-              <a:t>The PC was isolated before any file was encrypted</a:t>
-            </a:r>
-          </a:p>
-        </p:txBody>
-      </p:sp>
-      <p:sp>
-        <p:nvSpPr>
-          <p:cNvPr id="53" name="TextBox 52"/>
-          <p:cNvSpPr txBox="1"/>
-          <p:nvPr/>
-        </p:nvSpPr>
-        <p:spPr>
-          <a:xfrm>
-            <a:off x="548640" y="2800000"/>
-            <a:ext cx="11094415" cy="180000"/>
-          </a:xfrm>
-          <a:prstGeom prst="rect">
-            <a:avLst/>
-          </a:prstGeom>
-          <a:noFill/>
-        </p:spPr>
-        <p:txBody>
-          <a:bodyPr wrap="square" lIns="0" rIns="0" tIns="0" bIns="0" anchor="t">
-            <a:spAutoFit/>
-          </a:bodyPr>
-          <a:lstStyle/>
-          <a:p>
-            <a:pPr algn="l"/>
-            <a:r>
-              <a:rPr sz="850" b="0">
-                <a:solidFill>
-                  <a:srgbClr val="5E6978"/>
-                </a:solidFill>
-                <a:latin typeface="Calibri"/>
-              </a:rPr>
-              <a:t>Source: CrowdStrike case study (PUNK SPIDER, Akira ransomware). Steps simplified for readability.</a:t>
-            </a:r>
-          </a:p>
-        </p:txBody>
-      </p:sp>
-      <p:sp>
-        <p:nvSpPr>
-          <p:cNvPr id="54" name="Rounded Rectangle 53"/>
-          <p:cNvSpPr/>
-          <p:nvPr/>
-        </p:nvSpPr>
-        <p:spPr>
-          <a:xfrm>
-            <a:off x="548640" y="5120000"/>
-            <a:ext cx="11094415" cy="720000"/>
-          </a:xfrm>
-          <a:prstGeom prst="roundRect">
-            <a:avLst>
-              <a:gd name="adj" fmla="val 15000"/>
-            </a:avLst>
-          </a:prstGeom>
-          <a:solidFill>
-            <a:srgbClr val="1D2025"/>
-          </a:solidFill>
-          <a:ln>
-            <a:noFill/>
-          </a:ln>
-          <a:effectLst/>
-        </p:spPr>
-        <p:style>
-          <a:lnRef idx="1">
-            <a:schemeClr val="accent1"/>
-          </a:lnRef>
-          <a:fillRef idx="3">
-            <a:schemeClr val="accent1"/>
-          </a:fillRef>
-          <a:effectRef idx="2">
-            <a:schemeClr val="accent1"/>
-          </a:effectRef>
-          <a:fontRef idx="minor">
-            <a:schemeClr val="lt1"/>
-          </a:fontRef>
-        </p:style>
-        <p:txBody>
-          <a:bodyPr rtlCol="0" anchor="ctr"/>
-          <a:lstStyle/>
-          <a:p>
-            <a:pPr algn="ctr"/>
-          </a:p>
-        </p:txBody>
-      </p:sp>
-      <p:sp>
-        <p:nvSpPr>
-          <p:cNvPr id="55" name="TextBox 54"/>
-          <p:cNvSpPr txBox="1"/>
-          <p:nvPr/>
-        </p:nvSpPr>
-        <p:spPr>
-          <a:xfrm>
-            <a:off x="548640" y="5120000"/>
-            <a:ext cx="3698138" cy="720000"/>
-          </a:xfrm>
-          <a:prstGeom prst="rect">
-            <a:avLst/>
-          </a:prstGeom>
-          <a:noFill/>
-        </p:spPr>
-        <p:txBody>
-          <a:bodyPr wrap="square" lIns="0" rIns="0" tIns="0" bIns="0" anchor="ctr">
-            <a:spAutoFit/>
-          </a:bodyPr>
-          <a:lstStyle/>
-          <a:p>
-            <a:pPr algn="ctr"/>
-            <a:r>
-              <a:rPr sz="1600" b="1">
-                <a:solidFill>
-                  <a:srgbClr val="FF5A60"/>
-                </a:solidFill>
-                <a:latin typeface="Calibri"/>
-              </a:rPr>
-              <a:t>100% detection</a:t>
-            </a:r>
-          </a:p>
-          <a:p>
-            <a:pPr algn="ctr"/>
-            <a:r>
-              <a:rPr sz="1000" b="0">
-                <a:solidFill>
-                  <a:srgbClr val="D6DAE0"/>
-                </a:solidFill>
-                <a:latin typeface="Calibri"/>
-              </a:rPr>
-              <a:t>MITRE ATT&amp;CK® Evaluations 2025</a:t>
-            </a:r>
-          </a:p>
-        </p:txBody>
-      </p:sp>
-      <p:sp>
-        <p:nvSpPr>
-          <p:cNvPr id="56" name="TextBox 55"/>
-          <p:cNvSpPr txBox="1"/>
-          <p:nvPr/>
-        </p:nvSpPr>
-        <p:spPr>
-          <a:xfrm>
-            <a:off x="4246778" y="5120000"/>
-            <a:ext cx="3698138" cy="720000"/>
-          </a:xfrm>
-          <a:prstGeom prst="rect">
-            <a:avLst/>
-          </a:prstGeom>
-          <a:noFill/>
-        </p:spPr>
-        <p:txBody>
-          <a:bodyPr wrap="square" lIns="0" rIns="0" tIns="0" bIns="0" anchor="ctr">
-            <a:spAutoFit/>
-          </a:bodyPr>
-          <a:lstStyle/>
-          <a:p>
-            <a:pPr algn="ctr"/>
-            <a:r>
-              <a:rPr sz="1600" b="1">
-                <a:solidFill>
-                  <a:srgbClr val="FF5A60"/>
-                </a:solidFill>
-                <a:latin typeface="Calibri"/>
-              </a:rPr>
-              <a:t>Leader</a:t>
-            </a:r>
-          </a:p>
-          <a:p>
-            <a:pPr algn="ctr"/>
-            <a:r>
-              <a:rPr sz="1000" b="0">
-                <a:solidFill>
-                  <a:srgbClr val="D6DAE0"/>
-                </a:solidFill>
-                <a:latin typeface="Calibri"/>
-              </a:rPr>
-              <a:t>Gartner® Magic Quadrant™ for EPP</a:t>
-            </a:r>
-          </a:p>
-        </p:txBody>
-      </p:sp>
-      <p:sp>
-        <p:nvSpPr>
-          <p:cNvPr id="57" name="TextBox 56"/>
-          <p:cNvSpPr txBox="1"/>
-          <p:nvPr/>
-        </p:nvSpPr>
-        <p:spPr>
-          <a:xfrm>
-            <a:off x="7944916" y="5120000"/>
-            <a:ext cx="3698138" cy="720000"/>
-          </a:xfrm>
-          <a:prstGeom prst="rect">
-            <a:avLst/>
-          </a:prstGeom>
-          <a:noFill/>
-        </p:spPr>
-        <p:txBody>
-          <a:bodyPr wrap="square" lIns="0" rIns="0" tIns="0" bIns="0" anchor="ctr">
-            <a:spAutoFit/>
-          </a:bodyPr>
-          <a:lstStyle/>
-          <a:p>
-            <a:pPr algn="ctr"/>
-            <a:r>
-              <a:rPr sz="1600" b="1">
-                <a:solidFill>
-                  <a:srgbClr val="FF5A60"/>
-                </a:solidFill>
-                <a:latin typeface="Calibri"/>
-              </a:rPr>
-              <a:t>100% ransomware blocked</a:t>
-            </a:r>
-          </a:p>
-          <a:p>
-            <a:pPr algn="ctr"/>
-            <a:r>
-              <a:rPr sz="1000" b="0">
-                <a:solidFill>
-                  <a:srgbClr val="D6DAE0"/>
-                </a:solidFill>
-                <a:latin typeface="Calibri"/>
-              </a:rPr>
-              <a:t>SE Labs EDR Ransomware Test 2024</a:t>
             </a:r>
           </a:p>
         </p:txBody>
@@ -9966,7 +9114,7 @@
                 <a:ea typeface="Arial" pitchFamily="34" charset="-122"/>
                 <a:cs typeface="Arial" pitchFamily="34" charset="-120"/>
               </a:rPr>
-              <a:t>One Point of Contact</a:t>
+              <a:t>Direct, Accountable Support</a:t>
             </a:r>
             <a:endParaRPr lang="en-US" sz="1500" dirty="0"/>
           </a:p>
@@ -10005,7 +9153,7 @@
                 <a:ea typeface="Calibri" pitchFamily="34" charset="-122"/>
                 <a:cs typeface="Calibri" pitchFamily="34" charset="-120"/>
               </a:rPr>
-              <a:t>Support, licensing and renewals through one partner, with escalation to SK shieldus and CrowdStrike when needed.</a:t>
+              <a:t>SECUKOREA handles support, licensing and renewals directly, and stays with the resort from the first call to full resolution.</a:t>
             </a:r>
             <a:endParaRPr lang="en-US" sz="1200" dirty="0"/>
           </a:p>
@@ -10516,8 +9664,8 @@
         </p:blipFill>
         <p:spPr>
           <a:xfrm>
-            <a:off x="424065" y="4555236"/>
-            <a:ext cx="816077" cy="310244"/>
+            <a:off x="673364" y="4565660"/>
+            <a:ext cx="317480" cy="317480"/>
           </a:xfrm>
           <a:prstGeom prst="rect">
             <a:avLst/>
@@ -10779,7 +9927,7 @@
                 <a:ea typeface="Calibri" pitchFamily="34" charset="-122"/>
                 <a:cs typeface="Calibri" pitchFamily="34" charset="-120"/>
               </a:rPr>
-              <a:t>secukorea@secukorea.com</a:t>
+              <a:t>sales@secukorea.com</a:t>
             </a:r>
             <a:endParaRPr lang="en-US" sz="1400" dirty="0"/>
           </a:p>
@@ -11050,7 +10198,7 @@
     <a:fontScheme name="Office">
       <a:majorFont>
         <a:latin typeface="Calibri Light" panose="020F0302020204030204"/>
-        <a:ea typeface=""/>
+        <a:ea typeface="Malgun Gothic"/>
         <a:cs typeface=""/>
         <a:font script="Jpan" typeface="游ゴシック Light"/>
         <a:font script="Hang" typeface="맑은 고딕"/>
@@ -11102,7 +10250,7 @@
       </a:majorFont>
       <a:minorFont>
         <a:latin typeface="Calibri" panose="020F0502020204030204"/>
-        <a:ea typeface=""/>
+        <a:ea typeface="Malgun Gothic"/>
         <a:cs typeface=""/>
         <a:font script="Jpan" typeface="游ゴシック"/>
         <a:font script="Hang" typeface="맑은 고딕"/>

</xml_diff>

<commit_message>
CrowdStrike proposal: sync user's English edits and regenerate Korean version
Co-Authored-By: Claude Opus 5.5 <noreply@anthropic.com>
Claude-Session: https://claude.ai/code/session_01AC58wvp3ibSdWMcWgRepkj
</commit_message>
<xml_diff>
--- a/ENG._CrowdStrike_Falcon_Proposal_for_Westin_Resort_Guam_SECUKOREA.pptx
+++ b/ENG._CrowdStrike_Falcon_Proposal_for_Westin_Resort_Guam_SECUKOREA.pptx
@@ -1539,17 +1539,6 @@
               </a:rPr>
               <a:t>SECUKOREA Inc.</a:t>
             </a:r>
-            <a:r>
-              <a:rPr lang="ko-KR" altLang="en-US" sz="1500" dirty="0">
-                <a:solidFill>
-                  <a:srgbClr val="FFFFFF"/>
-                </a:solidFill>
-                <a:latin typeface="Calibri" pitchFamily="34" charset="0"/>
-                <a:ea typeface="Calibri" pitchFamily="34" charset="-122"/>
-                <a:cs typeface="Calibri" pitchFamily="34" charset="-120"/>
-              </a:rPr>
-              <a:t/>
-            </a:r>
             <a:endParaRPr lang="en-US" sz="1500" dirty="0"/>
           </a:p>
         </p:txBody>
@@ -2297,7 +2286,7 @@
               <a:buNone/>
             </a:pPr>
             <a:r>
-              <a:rPr lang="ko-KR" sz="1200" dirty="0">
+              <a:rPr lang="en-US" altLang="ko-KR" sz="1200">
                 <a:solidFill>
                   <a:srgbClr val="5E6978"/>
                 </a:solidFill>
@@ -2305,40 +2294,7 @@
                 <a:ea typeface="맑은 고딕" pitchFamily="34" charset="-122"/>
                 <a:cs typeface="Calibri" pitchFamily="34" charset="-120"/>
               </a:rPr>
-              <a:t>Nessus identifies vulnerabilities, but it does not block malware or stop an attack in progress. Every follow-up action is manual — and endpoints are left unprotected between scans.</a:t>
-            </a:r>
-            <a:r>
-              <a:rPr lang="en-US" altLang="ko-KR" sz="1200" dirty="0">
-                <a:solidFill>
-                  <a:srgbClr val="5E6978"/>
-                </a:solidFill>
-                <a:latin typeface="Calibri" pitchFamily="34" charset="0"/>
-                <a:ea typeface="맑은 고딕" pitchFamily="34" charset="-122"/>
-                <a:cs typeface="Calibri" pitchFamily="34" charset="-120"/>
-              </a:rPr>
-              <a:t/>
-            </a:r>
-            <a:r>
-              <a:rPr lang="ko-KR" altLang="en-US" sz="1200" dirty="0">
-                <a:solidFill>
-                  <a:srgbClr val="5E6978"/>
-                </a:solidFill>
-                <a:latin typeface="Calibri" pitchFamily="34" charset="0"/>
-                <a:ea typeface="맑은 고딕" pitchFamily="34" charset="-122"/>
-                <a:cs typeface="Calibri" pitchFamily="34" charset="-120"/>
-              </a:rPr>
-              <a:t/>
-            </a:r>
-            <a:r>
-              <a:rPr lang="en-US" altLang="ko-KR" sz="1200" dirty="0">
-                <a:solidFill>
-                  <a:srgbClr val="5E6978"/>
-                </a:solidFill>
-                <a:latin typeface="Calibri" pitchFamily="34" charset="0"/>
-                <a:ea typeface="맑은 고딕" pitchFamily="34" charset="-122"/>
-                <a:cs typeface="Calibri" pitchFamily="34" charset="-120"/>
-              </a:rPr>
-              <a:t/>
+              <a:t>A vulnerability scanner finds weaknesses, but it cannot block malware or stop an attack in progress. Every follow-up action is manual, and endpoints are left unprotected between scans.</a:t>
             </a:r>
             <a:endParaRPr lang="en-US" sz="1200" dirty="0"/>
           </a:p>
@@ -2467,7 +2423,51 @@
                 <a:ea typeface="맑은 고딕" pitchFamily="34" charset="-122"/>
                 <a:cs typeface="Calibri" pitchFamily="34" charset="-120"/>
               </a:rPr>
-              <a:t>Hotels hold payment card data and guest identities — a frequent target for ransomware and data theft, with direct impact on brand trust.</a:t>
+              <a:t>Hotels hold payment card data and </a:t>
+            </a:r>
+            <a:r>
+              <a:rPr lang="ko-KR" sz="1200">
+                <a:solidFill>
+                  <a:srgbClr val="5E6978"/>
+                </a:solidFill>
+                <a:latin typeface="Calibri" pitchFamily="34" charset="0"/>
+                <a:ea typeface="맑은 고딕" pitchFamily="34" charset="-122"/>
+                <a:cs typeface="Calibri" pitchFamily="34" charset="-120"/>
+              </a:rPr>
+              <a:t>guest identities</a:t>
+            </a:r>
+            <a:r>
+              <a:rPr lang="en-US" altLang="ko-KR" sz="1200">
+                <a:solidFill>
+                  <a:srgbClr val="5E6978"/>
+                </a:solidFill>
+                <a:latin typeface="Calibri" pitchFamily="34" charset="0"/>
+                <a:ea typeface="맑은 고딕" pitchFamily="34" charset="-122"/>
+                <a:cs typeface="Calibri" pitchFamily="34" charset="-120"/>
+              </a:rPr>
+              <a:t>. A</a:t>
+            </a:r>
+            <a:r>
+              <a:rPr lang="ko-KR" sz="1200">
+                <a:solidFill>
+                  <a:srgbClr val="5E6978"/>
+                </a:solidFill>
+                <a:latin typeface="Calibri" pitchFamily="34" charset="0"/>
+                <a:ea typeface="맑은 고딕" pitchFamily="34" charset="-122"/>
+                <a:cs typeface="Calibri" pitchFamily="34" charset="-120"/>
+              </a:rPr>
+              <a:t> </a:t>
+            </a:r>
+            <a:r>
+              <a:rPr lang="ko-KR" sz="1200" dirty="0">
+                <a:solidFill>
+                  <a:srgbClr val="5E6978"/>
+                </a:solidFill>
+                <a:latin typeface="Calibri" pitchFamily="34" charset="0"/>
+                <a:ea typeface="맑은 고딕" pitchFamily="34" charset="-122"/>
+                <a:cs typeface="Calibri" pitchFamily="34" charset="-120"/>
+              </a:rPr>
+              <a:t>frequent target for ransomware and data theft, with direct impact on brand trust.</a:t>
             </a:r>
             <a:endParaRPr lang="en-US" sz="1200" dirty="0"/>
           </a:p>
@@ -4749,47 +4749,6 @@
               </a:rPr>
               <a:t>Sensors on every endpoint spot danger the moment it appears, stop it automatically, and escalate to experts who are on duty around the clock.</a:t>
             </a:r>
-            <a:r>
-              <a:rPr lang="en-US" sz="1250" dirty="0" err="1">
-                <a:solidFill>
-                  <a:srgbClr val="5E6978"/>
-                </a:solidFill>
-                <a:latin typeface="Calibri" pitchFamily="34" charset="0"/>
-                <a:ea typeface="Calibri" pitchFamily="34" charset="-122"/>
-                <a:cs typeface="Calibri" pitchFamily="34" charset="-120"/>
-              </a:rPr>
-              <a:t/>
-            </a:r>
-            <a:r>
-              <a:rPr lang="en-US" sz="1250" dirty="0">
-                <a:solidFill>
-                  <a:srgbClr val="5E6978"/>
-                </a:solidFill>
-                <a:latin typeface="Calibri" pitchFamily="34" charset="0"/>
-                <a:ea typeface="Calibri" pitchFamily="34" charset="-122"/>
-                <a:cs typeface="Calibri" pitchFamily="34" charset="-120"/>
-              </a:rPr>
-              <a:t/>
-            </a:r>
-            <a:r>
-              <a:rPr lang="en-US" sz="1250" dirty="0" err="1">
-                <a:solidFill>
-                  <a:srgbClr val="5E6978"/>
-                </a:solidFill>
-                <a:latin typeface="Calibri" pitchFamily="34" charset="0"/>
-                <a:ea typeface="Calibri" pitchFamily="34" charset="-122"/>
-                <a:cs typeface="Calibri" pitchFamily="34" charset="-120"/>
-              </a:rPr>
-              <a:t/>
-            </a:r>
-            <a:endParaRPr lang="en-US" sz="1250" dirty="0">
-              <a:solidFill>
-                <a:srgbClr val="5E6978"/>
-              </a:solidFill>
-              <a:latin typeface="Calibri" pitchFamily="34" charset="0"/>
-              <a:ea typeface="Calibri" pitchFamily="34" charset="-122"/>
-              <a:cs typeface="Calibri" pitchFamily="34" charset="-120"/>
-            </a:endParaRPr>
           </a:p>
         </p:txBody>
       </p:sp>
@@ -5091,50 +5050,6 @@
                 <a:cs typeface="Calibri" pitchFamily="34" charset="-120"/>
               </a:rPr>
               <a:t> only tells you what is wrong.  </a:t>
-            </a:r>
-            <a:r>
-              <a:rPr lang="en-US" sz="1600">
-                <a:solidFill>
-                  <a:srgbClr val="5E6978"/>
-                </a:solidFill>
-                <a:latin typeface="Calibri" pitchFamily="34" charset="0"/>
-                <a:ea typeface="Calibri" pitchFamily="34" charset="-122"/>
-                <a:cs typeface="Calibri" pitchFamily="34" charset="-120"/>
-              </a:rPr>
-              <a:t/>
-            </a:r>
-            <a:r>
-              <a:rPr lang="ko-KR" altLang="en-US" sz="1600">
-                <a:solidFill>
-                  <a:srgbClr val="5E6978"/>
-                </a:solidFill>
-                <a:latin typeface="Calibri" pitchFamily="34" charset="0"/>
-                <a:ea typeface="Calibri" pitchFamily="34" charset="-122"/>
-                <a:cs typeface="Calibri" pitchFamily="34" charset="-120"/>
-              </a:rPr>
-              <a:t/>
-            </a:r>
-            <a:r>
-              <a:rPr lang="en-US" sz="1600">
-                <a:solidFill>
-                  <a:srgbClr val="5E6978"/>
-                </a:solidFill>
-                <a:latin typeface="Calibri" pitchFamily="34" charset="0"/>
-                <a:ea typeface="Calibri" pitchFamily="34" charset="-122"/>
-                <a:cs typeface="Calibri" pitchFamily="34" charset="-120"/>
-              </a:rPr>
-              <a:t/>
-            </a:r>
-            <a:r>
-              <a:rPr lang="en-US" sz="1600" dirty="0">
-                <a:solidFill>
-                  <a:srgbClr val="5E6978"/>
-                </a:solidFill>
-                <a:latin typeface="Calibri" pitchFamily="34" charset="0"/>
-                <a:ea typeface="Calibri" pitchFamily="34" charset="-122"/>
-                <a:cs typeface="Calibri" pitchFamily="34" charset="-120"/>
-              </a:rPr>
-              <a:t/>
             </a:r>
             <a:r>
               <a:rPr lang="en-US" sz="1600" b="1" dirty="0">
@@ -9153,7 +9068,18 @@
                 <a:ea typeface="Calibri" pitchFamily="34" charset="-122"/>
                 <a:cs typeface="Calibri" pitchFamily="34" charset="-120"/>
               </a:rPr>
-              <a:t>SECUKOREA handles support, licensing and renewals directly, and stays with the resort from the first call to full resolution.</a:t>
+              <a:t>SECUKOREA handles support, licensing and renewals directly, and stays with the resort from the first call to full </a:t>
+            </a:r>
+            <a:r>
+              <a:rPr lang="en-US" sz="1200">
+                <a:solidFill>
+                  <a:srgbClr val="5E6978"/>
+                </a:solidFill>
+                <a:latin typeface="Calibri" pitchFamily="34" charset="0"/>
+                <a:ea typeface="Calibri" pitchFamily="34" charset="-122"/>
+                <a:cs typeface="Calibri" pitchFamily="34" charset="-120"/>
+              </a:rPr>
+              <a:t>resolution. Escalation to SK shieldus when needed</a:t>
             </a:r>
             <a:endParaRPr lang="en-US" sz="1200" dirty="0"/>
           </a:p>

</xml_diff>